<commit_message>
Rework Week 7 final presentation script and slides (10-slide cut)
Rewrite the speaker script with delivery cues and per-slide timings,
condensing to a 10-slide narrative, and update the accompanying
Week7_Final_Presentation.pptx to match.
</commit_message>
<xml_diff>
--- a/docs/weekly-submissions/Week7_Final_Presentation.pptx
+++ b/docs/weekly-submissions/Week7_Final_Presentation.pptx
@@ -10,12 +10,9 @@
     <p:sldId id="258" r:id="rId10"/>
     <p:sldId id="259" r:id="rId11"/>
     <p:sldId id="260" r:id="rId12"/>
-    <p:sldId id="261" r:id="rId13"/>
     <p:sldId id="262" r:id="rId14"/>
     <p:sldId id="263" r:id="rId15"/>
-    <p:sldId id="264" r:id="rId16"/>
     <p:sldId id="265" r:id="rId17"/>
-    <p:sldId id="266" r:id="rId18"/>
     <p:sldId id="267" r:id="rId19"/>
     <p:sldId id="268" r:id="rId20"/>
   </p:sldIdLst>
@@ -514,7 +511,7 @@
           <a:lstStyle/>
           <a:p>
             <a:r>
-              <a:t>Good [morning/afternoon] everyone, thank you for the time. I'm Peng Fei Xu, presenting TrustResume, an evidence-based resume generation system built on retrieval-augmented generation, multi-agent AI, and an independent trust-verification layer. This is the final presentation for my MSAI 699 capstone. I'll walk through the problem, how the system works, what the data shows, and where it goes from here.</a:t>
+              <a:t>Let me start with a question. If an AI tool writes your resume in seconds — who checks that every claim in it is actually true? Right now, nobody does. That gap is what my project closes. I'm Peng Fei Xu, and this is TrustResume, my MSAI 699 capstone: it generates a resume from real evidence, and then independently verifies every claim before delivering it. I'll cover the problem, how it works, the results, and what it means for the people who use it.</a:t>
             </a:r>
           </a:p>
         </p:txBody>
@@ -584,7 +581,7 @@
           <a:lstStyle/>
           <a:p>
             <a:r>
-              <a:t>A few words on responsible design, since this touches real people's careers. Security: any external text, such as a posting or an uploaded document, is tagged as data, never an instruction, defending against prompt injection. Fairness: the same verification that catches fabrication also protects against a subtler bias: an unchecked generator would favor whichever candidate's background happens to embellish most convincingly. Privacy: every record and search is scoped to one user's own data. And I want to be upfront: the deployed API currently identifies a caller from a self-reported header. That's enough to prove isolation works, but not real authentication. That's the clearest gap before a real multi-tenant deployment.</a:t>
+              <a:t>Two quick things, because this touches real careers. First, responsible design: every outside input is treated as data, never as an instruction, which defends against prompt injection; every user's data is isolated; and the same verification that catches fabrication also keeps the system fair — it won't reward whoever embellishes best. Second, what's next, in four areas: real authentication and security; better retrieval with a relevance threshold; higher trust accuracy from a larger labeled dataset; and scalability plus more export languages. I'll be honest — real login isn't built yet, and it's the top priority.</a:t>
             </a:r>
           </a:p>
         </p:txBody>
@@ -724,7 +721,7 @@
           <a:lstStyle/>
           <a:p>
             <a:r>
-              <a:t>To close, three takeaways. One: generation and verification don't have to be the same step trusting itself. Separating them is what makes an AI system's claims checkable, not just plausible. Two: we proved it, not just claimed it. A real model, faced with a job it couldn't honestly match, chose a perfect trust score over inventing experience, and our own evaluation harness caught and let us fix a real flaw in the verifier before it reached a user. Three: this pattern isn't specific to résumés. Any AI system generating content where truthfulness matters can ground it in real evidence and check it independently before anyone sees it. Thank you, and happy to take questions.</a:t>
+              <a:t>To conclude. The big idea is simple: AI-generated content can be useful without sacrificing trust — and the key is independent verification. We didn't just claim that; we proved it on a real model that chose an honest score over a fabricated resume. For candidates, that means a resume they can stand behind. For employers, claims they can actually trust. And this pattern — grounded generation plus independent verification — reaches far beyond resumes, to any AI-generated content where the truth matters. Thank you.</a:t>
             </a:r>
           </a:p>
         </p:txBody>
@@ -794,7 +791,7 @@
           <a:lstStyle/>
           <a:p>
             <a:r>
-              <a:t>Thank you again for your time. I'd be glad to take any questions.</a:t>
+              <a:t>Thank you very much for your time. I'd be glad to take any questions.</a:t>
             </a:r>
           </a:p>
         </p:txBody>
@@ -864,7 +861,7 @@
           <a:lstStyle/>
           <a:p>
             <a:r>
-              <a:t>Let's start with the problem. Generative AI can write a convincing resume in seconds. That part is solved. The problem is nothing stops it from quietly stretching the truth: bumping '2 years' to 'senior', turning a real 64 percent improvement into a rounder 90 percent. That's the easiest way for a model to make a draft look better, so without a check, it happens by default. And the cost isn't abstract: candidates lose credibility, employers make bad hiring decisions, and every legitimate use of AI in hiring gets painted with the same brush. So the question driving this project: can we build a system that generates a strong resume and can prove, claim by claim, that it's true?</a:t>
+              <a:t>Generative AI can write a convincing resume in seconds — that part is solved. The real problem is trust. Nothing stops the model from stretching the truth, and a fabricated claim looks exactly like a real one. Why does this matter? For candidates, one claim they can't back up can cost them their credibility. For employers, it means wasted time and bad hires. And for organizations, unverifiable AI content is a real legal and reputational risk. So this isn't just a technical problem — it affects everyone in hiring.</a:t>
             </a:r>
           </a:p>
         </p:txBody>
@@ -934,7 +931,7 @@
           <a:lstStyle/>
           <a:p>
             <a:r>
-              <a:t>The solution is architectural. First, retrieval-augmented generation: instead of inventing a resume, we retrieve the candidate's own documents and ground the draft in that evidence. Second, the key idea: generation and verification are separate agents. The writer never grades its own homework. An independent Trust Harness checks every claim against the evidence, scored against a Trust gate and an ATS gate, and the system always rewrites at least once more, whether or not the draft already cleared both gates, then ships whichever draft actually scored best. The bet this project is built on: it should rather fail a candidate than lie for them. I'll show a real example later.</a:t>
+              <a:t>Here is the core innovation — and it is NOT the tech stack. It is this one idea: every claim in the resume is independently verified against the candidate's own evidence, before the resume is delivered. Most AI tools let the model write, and then effectively trust itself. We split those two jobs. A Writer agent generates the resume. Then a completely separate Verifier checks every single claim against the evidence. The writer never grades its own homework. That independent verification layer is the whole point of this project.</a:t>
             </a:r>
           </a:p>
         </p:txBody>
@@ -1004,7 +1001,7 @@
           <a:lstStyle/>
           <a:p>
             <a:r>
-              <a:t>Here's the architecture. Job Description and Evidence Retrieval each run once. Retrieval uses a hybrid search, part vector similarity, part keyword, so it catches both a paraphrase and an exact product name. Those feed a loop: the Resume Writer drafts, the Trust Harness scores every claim as supported, partially supported, or unsupported, and ATS Evaluation scores keyword coverage. The system builds specific feedback from whatever's weakest and tries again, always, for a configurable number of rewrites, whether or not an earlier draft already cleared both gates, then keeps whichever draft actually scored best rather than whichever one happened to pass first. A sixth agent, a cached Candidate Profile, feeds the writer without being recomputed every time. This all runs as a graph, LangGraph, which makes the loop and the stopping condition explicit and testable, not buried in ad hoc code.</a:t>
+              <a:t>Here is the method in one picture. Two steps run once: we read the job, and we retrieve the candidate's evidence. Then a loop begins. The Writer drafts. The Verifier — our Trust Harness — scores every claim as supported, partly supported, or unsupported. An ATS check scores keyword coverage against the job. The system writes feedback from whatever is weakest, tries again, and in the end keeps the best-scoring draft, not just the last one. Generation and verification are always separate steps in that loop.</a:t>
             </a:r>
           </a:p>
         </p:txBody>
@@ -1074,7 +1071,7 @@
           <a:lstStyle/>
           <a:p>
             <a:r>
-              <a:t>A few engineering choices matter here because they make this deployable, not just a proof of concept. It's provider-agnostic: it runs on AWS Bedrock, OpenAI, or Google Gemini, chosen by configuration, not by rewriting code, so there's no vendor lock-in. Sampling temperature is pinned to zero, because the headline promise is a deterministic, code-computed trust score. If the same resume could score differently on two runs, that promise wouldn't hold. Models are tiered by role: a cheap model handles simple extraction, a stronger one is reserved for writing and for the verifier, the one place skimping actually hurts. And every request is scoped to one user's own data: the isolation boundary the whole trust story depends on.</a:t>
+              <a:t>A quick architecture walkthrough. On the left is the path a request takes: the web UI talks over HTTP to a thin API layer, which calls one application service, which calls the Orchestrator. In the middle are the six agents the Orchestrator runs in order — the green ones use no AI model at all, so retrieval and scoring are plain, testable code, not a black box. At the bottom is storage, with hybrid search that combines meaning-based and keyword search. The key design point for stakeholders: every search is scoped to one user's own data, and the scoring logic has no AI model inside it — so the trust score is deterministic and auditable.</a:t>
             </a:r>
           </a:p>
         </p:txBody>
@@ -1214,7 +1211,7 @@
           <a:lstStyle/>
           <a:p>
             <a:r>
-              <a:t>Here's what the data shows. On the left: retrieval finds the right evidence 100 percent of the time in our labeled test set. The Trust Harness chart is more interesting: the first version of the verifier's instructions only scored 50 percent accuracy, because it said 'be strict' without defining what that meant, so it downgraded almost everything by one notch. Explicit definitions pushed accuracy to over 83 percent, and the dangerous error, something false marked true, stayed at zero the whole time. On the right: four real runs against a production Bedrock model. Three of four fail the quality gate, on purpose. A gate that never says no isn't checking anything.</a:t>
+              <a:t>Now the results — and the point here is that we measured, we didn't assume. Three headline numbers. One: retrieval finds the right evidence 100 percent of the time on our labeled test set. Two: the verifier is 83.3 percent accurate. And here's the honest data-analysis story behind that number — the first version scored only 50 percent, because we just told it to 'be strict' without defining what that meant. We caught that with our own evaluation harness and calibrated it up to 83.3 percent. And the dangerous error — a false claim marked as true — stayed at zero the whole time. Three: 99.2 percent test coverage, 500 automated tests on every change.</a:t>
             </a:r>
           </a:p>
         </p:txBody>
@@ -1284,7 +1281,7 @@
           <a:lstStyle/>
           <a:p>
             <a:r>
-              <a:t>This is the slide I most want you to remember. Same candidate, four job postings, run against a real production model, each drafted twice since the loop no longer stops the moment a draft passes. Scenario one is a genuine match: the first draft already passed, the second draft passed too but scored lower on ATS, and the system correctly kept the first one instead of whatever ran last. Scenario four matters most: an iOS posting for a backend candidate with zero iOS experience. The writer refused to invent any. Trust score: a perfect 100, because every claim was true. ATS score: zero, because the resume matches no required keyword. Trust 100, ATS 0, same résumé. That's not a bug. That's the entire product thesis, visible in two numbers. And scenario three shows the harness earning its keep under pressure: asked for scope beyond the evidence, the writer drifted toward exaggeration, and verification caught every one of those claims before anyone saw them.</a:t>
+              <a:t>This is the slide I most want you to remember. We took a backend engineer's real resume and applied it to an iOS Developer job — a candidate with zero iOS experience. Look at the two numbers. The Trust Score is 100: every claim the system made was true. The ATS match is 0: there was no matching experience, and the writer refused to invent any. So instead of faking an iOS background to pass, the system reported an honest failure. It would rather fail you than lie for you. That is the entire thesis of this project, proven on a real production model.</a:t>
             </a:r>
           </a:p>
         </p:txBody>
@@ -4506,6 +4503,87 @@
           </a:p>
         </p:txBody>
       </p:sp>
+      <p:sp>
+        <p:nvSpPr>
+          <p:cNvPr id="6" name="Rounded Rectangle 5"/>
+          <p:cNvSpPr/>
+          <p:nvPr/>
+        </p:nvSpPr>
+        <p:spPr>
+          <a:xfrm>
+            <a:off x="914400" y="4370832"/>
+            <a:ext cx="10332720" cy="713232"/>
+          </a:xfrm>
+          <a:prstGeom prst="roundRect">
+            <a:avLst>
+              <a:gd name="adj" fmla="val 6000"/>
+            </a:avLst>
+          </a:prstGeom>
+          <a:solidFill>
+            <a:srgbClr val="FFFFFF"/>
+          </a:solidFill>
+          <a:ln>
+            <a:noFill/>
+          </a:ln>
+          <a:effectLst/>
+        </p:spPr>
+        <p:style>
+          <a:lnRef idx="1">
+            <a:schemeClr val="accent1"/>
+          </a:lnRef>
+          <a:fillRef idx="3">
+            <a:schemeClr val="accent1"/>
+          </a:fillRef>
+          <a:effectRef idx="2">
+            <a:schemeClr val="accent1"/>
+          </a:effectRef>
+          <a:fontRef idx="minor">
+            <a:schemeClr val="lt1"/>
+          </a:fontRef>
+        </p:style>
+        <p:txBody>
+          <a:bodyPr rtlCol="0" anchor="ctr"/>
+          <a:lstStyle/>
+          <a:p>
+            <a:pPr algn="ctr"/>
+          </a:p>
+        </p:txBody>
+      </p:sp>
+      <p:sp>
+        <p:nvSpPr>
+          <p:cNvPr id="7" name="TextBox 6"/>
+          <p:cNvSpPr txBox="1"/>
+          <p:nvPr/>
+        </p:nvSpPr>
+        <p:spPr>
+          <a:xfrm>
+            <a:off x="914400" y="4370832"/>
+            <a:ext cx="10332720" cy="713232"/>
+          </a:xfrm>
+          <a:prstGeom prst="rect">
+            <a:avLst/>
+          </a:prstGeom>
+          <a:noFill/>
+        </p:spPr>
+        <p:txBody>
+          <a:bodyPr wrap="square" anchor="ctr" tIns="27432" bIns="27432">
+            <a:spAutoFit/>
+          </a:bodyPr>
+          <a:lstStyle/>
+          <a:p>
+            <a:pPr algn="ctr"/>
+            <a:r>
+              <a:rPr sz="2200" b="1" i="1">
+                <a:solidFill>
+                  <a:srgbClr val="4C72B0"/>
+                </a:solidFill>
+                <a:latin typeface="Calibri"/>
+              </a:rPr>
+              <a:t>If AI writes your resume — who verifies that every claim is true?</a:t>
+            </a:r>
+          </a:p>
+        </p:txBody>
+      </p:sp>
     </p:spTree>
   </p:cSld>
   <p:clrMapOvr>
@@ -4641,21 +4719,21 @@
                 </a:solidFill>
                 <a:latin typeface="Calibri"/>
               </a:rPr>
-              <a:t>Responsible by Design</a:t>
-            </a:r>
-          </a:p>
-        </p:txBody>
-      </p:sp>
-      <p:sp>
-        <p:nvSpPr>
-          <p:cNvPr id="5" name="TextBox 4"/>
+              <a:t>Responsible AI &amp; What’s Next</a:t>
+            </a:r>
+          </a:p>
+        </p:txBody>
+      </p:sp>
+      <p:sp>
+        <p:nvSpPr>
+          <p:cNvPr id="6" name="TextBox 5"/>
           <p:cNvSpPr txBox="1"/>
           <p:nvPr/>
         </p:nvSpPr>
         <p:spPr>
           <a:xfrm>
-            <a:off x="640080" y="1417320"/>
-            <a:ext cx="10911535" cy="4846320"/>
+            <a:off x="640080" y="6446520"/>
+            <a:ext cx="10911535" cy="320040"/>
           </a:xfrm>
           <a:prstGeom prst="rect">
             <a:avLst/>
@@ -4668,81 +4746,76 @@
           </a:bodyPr>
           <a:lstStyle/>
           <a:p>
-            <a:pPr>
-              <a:spcAft>
-                <a:spcPts val="1400"/>
-              </a:spcAft>
-            </a:pPr>
-            <a:r>
-              <a:rPr sz="2000" b="0" i="0">
-                <a:solidFill>
-                  <a:srgbClr val="2A2A2A"/>
-                </a:solidFill>
-                <a:latin typeface="Calibri"/>
-              </a:rPr>
-              <a:t>•  Security: every piece of external text, such as a job posting or an uploaded document, is clearly marked as data, not instructions, defending against prompt injection.</a:t>
-            </a:r>
-          </a:p>
-          <a:p>
-            <a:pPr>
-              <a:spcAft>
-                <a:spcPts val="1400"/>
-              </a:spcAft>
-            </a:pPr>
-            <a:r>
-              <a:rPr sz="2000" b="0" i="0">
-                <a:solidFill>
-                  <a:srgbClr val="2A2A2A"/>
-                </a:solidFill>
-                <a:latin typeface="Calibri"/>
-              </a:rPr>
-              <a:t>•  Fairness: the same verification that catches fabrication also prevents the system from rewarding whichever candidate's background happens to embellish best.</a:t>
-            </a:r>
-          </a:p>
-          <a:p>
-            <a:pPr>
-              <a:spcAft>
-                <a:spcPts val="1400"/>
-              </a:spcAft>
-            </a:pPr>
-            <a:r>
-              <a:rPr sz="2000" b="0" i="0">
-                <a:solidFill>
-                  <a:srgbClr val="2A2A2A"/>
-                </a:solidFill>
-                <a:latin typeface="Calibri"/>
-              </a:rPr>
-              <a:t>•  Privacy: every record is isolated per user and filtered server-side on every search.</a:t>
-            </a:r>
-          </a:p>
-          <a:p>
-            <a:pPr>
-              <a:spcAft>
-                <a:spcPts val="1400"/>
-              </a:spcAft>
-            </a:pPr>
-            <a:r>
-              <a:rPr sz="2000" b="0" i="0">
-                <a:solidFill>
-                  <a:srgbClr val="2A2A2A"/>
-                </a:solidFill>
-                <a:latin typeface="Calibri"/>
-              </a:rPr>
-              <a:t>•  Known gap: the deployed API identifies a caller from a self-reported header. Real authentication is on the roadmap, not yet built.</a:t>
-            </a:r>
-          </a:p>
-        </p:txBody>
-      </p:sp>
-      <p:sp>
-        <p:nvSpPr>
-          <p:cNvPr id="6" name="TextBox 5"/>
+            <a:r>
+              <a:rPr sz="1100" b="0" i="0">
+                <a:solidFill>
+                  <a:srgbClr val="6B6B6B"/>
+                </a:solidFill>
+                <a:latin typeface="Calibri"/>
+              </a:rPr>
+              <a:t>TrustResume | MSAI 699 Capstone Final Presentation</a:t>
+            </a:r>
+          </a:p>
+        </p:txBody>
+      </p:sp>
+      <p:sp>
+        <p:nvSpPr>
+          <p:cNvPr id="7" name="Rounded Rectangle 6"/>
+          <p:cNvSpPr/>
+          <p:nvPr/>
+        </p:nvSpPr>
+        <p:spPr>
+          <a:xfrm>
+            <a:off x="640080" y="1417320"/>
+            <a:ext cx="5303520" cy="4251960"/>
+          </a:xfrm>
+          <a:prstGeom prst="roundRect">
+            <a:avLst>
+              <a:gd name="adj" fmla="val 6000"/>
+            </a:avLst>
+          </a:prstGeom>
+          <a:solidFill>
+            <a:srgbClr val="E9EFF8"/>
+          </a:solidFill>
+          <a:ln w="15875">
+            <a:solidFill>
+              <a:srgbClr val="C7D6EC"/>
+            </a:solidFill>
+          </a:ln>
+          <a:effectLst/>
+        </p:spPr>
+        <p:style>
+          <a:lnRef idx="1">
+            <a:schemeClr val="accent1"/>
+          </a:lnRef>
+          <a:fillRef idx="3">
+            <a:schemeClr val="accent1"/>
+          </a:fillRef>
+          <a:effectRef idx="2">
+            <a:schemeClr val="accent1"/>
+          </a:effectRef>
+          <a:fontRef idx="minor">
+            <a:schemeClr val="lt1"/>
+          </a:fontRef>
+        </p:style>
+        <p:txBody>
+          <a:bodyPr rtlCol="0" anchor="ctr"/>
+          <a:lstStyle/>
+          <a:p>
+            <a:pPr algn="ctr"/>
+          </a:p>
+        </p:txBody>
+      </p:sp>
+      <p:sp>
+        <p:nvSpPr>
+          <p:cNvPr id="8" name="TextBox 7"/>
           <p:cNvSpPr txBox="1"/>
           <p:nvPr/>
         </p:nvSpPr>
         <p:spPr>
           <a:xfrm>
-            <a:off x="640080" y="6446520"/>
-            <a:ext cx="10911535" cy="320040"/>
+            <a:off x="868680" y="1600200"/>
+            <a:ext cx="4892040" cy="3931920"/>
           </a:xfrm>
           <a:prstGeom prst="rect">
             <a:avLst/>
@@ -4750,19 +4823,333 @@
           <a:noFill/>
         </p:spPr>
         <p:txBody>
-          <a:bodyPr wrap="square">
+          <a:bodyPr wrap="square" anchor="t" tIns="27432" bIns="27432">
             <a:spAutoFit/>
           </a:bodyPr>
           <a:lstStyle/>
           <a:p>
-            <a:r>
-              <a:rPr sz="1100" b="0" i="0">
-                <a:solidFill>
-                  <a:srgbClr val="6B6B6B"/>
-                </a:solidFill>
-                <a:latin typeface="Calibri"/>
-              </a:rPr>
-              <a:t>TrustResume | MSAI 699 Capstone Final Presentation</a:t>
+            <a:pPr algn="l">
+              <a:lnSpc>
+                <a:spcPct val="105000"/>
+              </a:lnSpc>
+            </a:pPr>
+            <a:r>
+              <a:rPr sz="2000" b="1" i="0">
+                <a:solidFill>
+                  <a:srgbClr val="4C72B0"/>
+                </a:solidFill>
+                <a:latin typeface="Calibri"/>
+              </a:rPr>
+              <a:t>Responsible by design</a:t>
+            </a:r>
+          </a:p>
+          <a:p>
+            <a:pPr algn="l">
+              <a:lnSpc>
+                <a:spcPct val="105000"/>
+              </a:lnSpc>
+            </a:pPr>
+            <a:r>
+              <a:rPr sz="800" b="0" i="0">
+                <a:solidFill>
+                  <a:srgbClr val="2A2A2A"/>
+                </a:solidFill>
+                <a:latin typeface="Calibri"/>
+              </a:rPr>
+              <a:t/>
+            </a:r>
+          </a:p>
+          <a:p>
+            <a:pPr algn="l">
+              <a:lnSpc>
+                <a:spcPct val="105000"/>
+              </a:lnSpc>
+            </a:pPr>
+            <a:r>
+              <a:rPr sz="1700" b="0" i="0">
+                <a:solidFill>
+                  <a:srgbClr val="2A2A2A"/>
+                </a:solidFill>
+                <a:latin typeface="Calibri"/>
+              </a:rPr>
+              <a:t>Security — every input is treated as data, not instructions (prompt-injection defense).</a:t>
+            </a:r>
+          </a:p>
+          <a:p>
+            <a:pPr algn="l">
+              <a:lnSpc>
+                <a:spcPct val="105000"/>
+              </a:lnSpc>
+            </a:pPr>
+            <a:r>
+              <a:rPr sz="600" b="0" i="0">
+                <a:solidFill>
+                  <a:srgbClr val="2A2A2A"/>
+                </a:solidFill>
+                <a:latin typeface="Calibri"/>
+              </a:rPr>
+              <a:t/>
+            </a:r>
+          </a:p>
+          <a:p>
+            <a:pPr algn="l">
+              <a:lnSpc>
+                <a:spcPct val="105000"/>
+              </a:lnSpc>
+            </a:pPr>
+            <a:r>
+              <a:rPr sz="1700" b="0" i="0">
+                <a:solidFill>
+                  <a:srgbClr val="2A2A2A"/>
+                </a:solidFill>
+                <a:latin typeface="Calibri"/>
+              </a:rPr>
+              <a:t>Privacy — every user’s data is isolated and filtered on the server.</a:t>
+            </a:r>
+          </a:p>
+          <a:p>
+            <a:pPr algn="l">
+              <a:lnSpc>
+                <a:spcPct val="105000"/>
+              </a:lnSpc>
+            </a:pPr>
+            <a:r>
+              <a:rPr sz="600" b="0" i="0">
+                <a:solidFill>
+                  <a:srgbClr val="2A2A2A"/>
+                </a:solidFill>
+                <a:latin typeface="Calibri"/>
+              </a:rPr>
+              <a:t/>
+            </a:r>
+          </a:p>
+          <a:p>
+            <a:pPr algn="l">
+              <a:lnSpc>
+                <a:spcPct val="105000"/>
+              </a:lnSpc>
+            </a:pPr>
+            <a:r>
+              <a:rPr sz="1700" b="0" i="0">
+                <a:solidFill>
+                  <a:srgbClr val="2A2A2A"/>
+                </a:solidFill>
+                <a:latin typeface="Calibri"/>
+              </a:rPr>
+              <a:t>Fairness — the same verification stops the system from rewarding whoever embellishes best.</a:t>
+            </a:r>
+          </a:p>
+        </p:txBody>
+      </p:sp>
+      <p:sp>
+        <p:nvSpPr>
+          <p:cNvPr id="9" name="Rounded Rectangle 8"/>
+          <p:cNvSpPr/>
+          <p:nvPr/>
+        </p:nvSpPr>
+        <p:spPr>
+          <a:xfrm>
+            <a:off x="6245352" y="1417320"/>
+            <a:ext cx="5303520" cy="4251960"/>
+          </a:xfrm>
+          <a:prstGeom prst="roundRect">
+            <a:avLst>
+              <a:gd name="adj" fmla="val 6000"/>
+            </a:avLst>
+          </a:prstGeom>
+          <a:solidFill>
+            <a:srgbClr val="FBEFE6"/>
+          </a:solidFill>
+          <a:ln>
+            <a:noFill/>
+          </a:ln>
+          <a:effectLst/>
+        </p:spPr>
+        <p:style>
+          <a:lnRef idx="1">
+            <a:schemeClr val="accent1"/>
+          </a:lnRef>
+          <a:fillRef idx="3">
+            <a:schemeClr val="accent1"/>
+          </a:fillRef>
+          <a:effectRef idx="2">
+            <a:schemeClr val="accent1"/>
+          </a:effectRef>
+          <a:fontRef idx="minor">
+            <a:schemeClr val="lt1"/>
+          </a:fontRef>
+        </p:style>
+        <p:txBody>
+          <a:bodyPr rtlCol="0" anchor="ctr"/>
+          <a:lstStyle/>
+          <a:p>
+            <a:pPr algn="ctr"/>
+          </a:p>
+        </p:txBody>
+      </p:sp>
+      <p:sp>
+        <p:nvSpPr>
+          <p:cNvPr id="10" name="TextBox 9"/>
+          <p:cNvSpPr txBox="1"/>
+          <p:nvPr/>
+        </p:nvSpPr>
+        <p:spPr>
+          <a:xfrm>
+            <a:off x="6473952" y="1600200"/>
+            <a:ext cx="4892040" cy="3931920"/>
+          </a:xfrm>
+          <a:prstGeom prst="rect">
+            <a:avLst/>
+          </a:prstGeom>
+          <a:noFill/>
+        </p:spPr>
+        <p:txBody>
+          <a:bodyPr wrap="square" anchor="t" tIns="27432" bIns="27432">
+            <a:spAutoFit/>
+          </a:bodyPr>
+          <a:lstStyle/>
+          <a:p>
+            <a:pPr algn="l">
+              <a:lnSpc>
+                <a:spcPct val="105000"/>
+              </a:lnSpc>
+            </a:pPr>
+            <a:r>
+              <a:rPr sz="2000" b="1" i="0">
+                <a:solidFill>
+                  <a:srgbClr val="DD8452"/>
+                </a:solidFill>
+                <a:latin typeface="Calibri"/>
+              </a:rPr>
+              <a:t>What’s next — four focus areas</a:t>
+            </a:r>
+          </a:p>
+          <a:p>
+            <a:pPr algn="l">
+              <a:lnSpc>
+                <a:spcPct val="105000"/>
+              </a:lnSpc>
+            </a:pPr>
+            <a:r>
+              <a:rPr sz="800" b="0" i="0">
+                <a:solidFill>
+                  <a:srgbClr val="2A2A2A"/>
+                </a:solidFill>
+                <a:latin typeface="Calibri"/>
+              </a:rPr>
+              <a:t/>
+            </a:r>
+          </a:p>
+          <a:p>
+            <a:pPr algn="l">
+              <a:lnSpc>
+                <a:spcPct val="105000"/>
+              </a:lnSpc>
+            </a:pPr>
+            <a:r>
+              <a:rPr sz="1700" b="0" i="0">
+                <a:solidFill>
+                  <a:srgbClr val="2A2A2A"/>
+                </a:solidFill>
+                <a:latin typeface="Calibri"/>
+              </a:rPr>
+              <a:t>1.  Authentication &amp; Security — real login, rate limiting</a:t>
+            </a:r>
+          </a:p>
+          <a:p>
+            <a:pPr algn="l">
+              <a:lnSpc>
+                <a:spcPct val="105000"/>
+              </a:lnSpc>
+            </a:pPr>
+            <a:r>
+              <a:rPr sz="600" b="0" i="0">
+                <a:solidFill>
+                  <a:srgbClr val="2A2A2A"/>
+                </a:solidFill>
+                <a:latin typeface="Calibri"/>
+              </a:rPr>
+              <a:t/>
+            </a:r>
+          </a:p>
+          <a:p>
+            <a:pPr algn="l">
+              <a:lnSpc>
+                <a:spcPct val="105000"/>
+              </a:lnSpc>
+            </a:pPr>
+            <a:r>
+              <a:rPr sz="1700" b="0" i="0">
+                <a:solidFill>
+                  <a:srgbClr val="2A2A2A"/>
+                </a:solidFill>
+                <a:latin typeface="Calibri"/>
+              </a:rPr>
+              <a:t>2.  Retrieval Quality — a relevance threshold on search</a:t>
+            </a:r>
+          </a:p>
+          <a:p>
+            <a:pPr algn="l">
+              <a:lnSpc>
+                <a:spcPct val="105000"/>
+              </a:lnSpc>
+            </a:pPr>
+            <a:r>
+              <a:rPr sz="600" b="0" i="0">
+                <a:solidFill>
+                  <a:srgbClr val="2A2A2A"/>
+                </a:solidFill>
+                <a:latin typeface="Calibri"/>
+              </a:rPr>
+              <a:t/>
+            </a:r>
+          </a:p>
+          <a:p>
+            <a:pPr algn="l">
+              <a:lnSpc>
+                <a:spcPct val="105000"/>
+              </a:lnSpc>
+            </a:pPr>
+            <a:r>
+              <a:rPr sz="1700" b="0" i="0">
+                <a:solidFill>
+                  <a:srgbClr val="2A2A2A"/>
+                </a:solidFill>
+                <a:latin typeface="Calibri"/>
+              </a:rPr>
+              <a:t>3.  Trust Accuracy — a larger labeled dataset</a:t>
+            </a:r>
+          </a:p>
+          <a:p>
+            <a:pPr algn="l">
+              <a:lnSpc>
+                <a:spcPct val="105000"/>
+              </a:lnSpc>
+            </a:pPr>
+            <a:r>
+              <a:rPr sz="600" b="0" i="0">
+                <a:solidFill>
+                  <a:srgbClr val="2A2A2A"/>
+                </a:solidFill>
+                <a:latin typeface="Calibri"/>
+              </a:rPr>
+              <a:t/>
+            </a:r>
+          </a:p>
+          <a:p>
+            <a:pPr algn="l">
+              <a:lnSpc>
+                <a:spcPct val="105000"/>
+              </a:lnSpc>
+            </a:pPr>
+            <a:r>
+              <a:rPr sz="1700" b="0" i="0">
+                <a:solidFill>
+                  <a:srgbClr val="2A2A2A"/>
+                </a:solidFill>
+                <a:latin typeface="Calibri"/>
+              </a:rPr>
+              <a:t>4.  Scalability &amp; Language Support — scale-out, more export languages</a:t>
             </a:r>
           </a:p>
         </p:txBody>
@@ -5163,21 +5550,21 @@
                 </a:solidFill>
                 <a:latin typeface="Calibri"/>
               </a:rPr>
-              <a:t>Key Takeaways</a:t>
-            </a:r>
-          </a:p>
-        </p:txBody>
-      </p:sp>
-      <p:sp>
-        <p:nvSpPr>
-          <p:cNvPr id="5" name="TextBox 4"/>
+              <a:t>Conclusion</a:t>
+            </a:r>
+          </a:p>
+        </p:txBody>
+      </p:sp>
+      <p:sp>
+        <p:nvSpPr>
+          <p:cNvPr id="6" name="TextBox 5"/>
           <p:cNvSpPr txBox="1"/>
           <p:nvPr/>
         </p:nvSpPr>
         <p:spPr>
           <a:xfrm>
-            <a:off x="640080" y="1417320"/>
-            <a:ext cx="10911535" cy="4846320"/>
+            <a:off x="640080" y="6446520"/>
+            <a:ext cx="10911535" cy="320040"/>
           </a:xfrm>
           <a:prstGeom prst="rect">
             <a:avLst/>
@@ -5190,81 +5577,76 @@
           </a:bodyPr>
           <a:lstStyle/>
           <a:p>
-            <a:pPr>
-              <a:spcAft>
-                <a:spcPts val="1400"/>
-              </a:spcAft>
-            </a:pPr>
-            <a:r>
-              <a:rPr sz="2000" b="0" i="0">
-                <a:solidFill>
-                  <a:srgbClr val="2A2A2A"/>
-                </a:solidFill>
-                <a:latin typeface="Calibri"/>
-              </a:rPr>
-              <a:t>•  AI can generate content and independently verify it: generation and verification don't have to be the same step trusting itself.</a:t>
-            </a:r>
-          </a:p>
-          <a:p>
-            <a:pPr>
-              <a:spcAft>
-                <a:spcPts val="1400"/>
-              </a:spcAft>
-            </a:pPr>
-            <a:r>
-              <a:rPr sz="2000" b="0" i="0">
-                <a:solidFill>
-                  <a:srgbClr val="2A2A2A"/>
-                </a:solidFill>
-                <a:latin typeface="Calibri"/>
-              </a:rPr>
-              <a:t>•  We proved it empirically: a real production model, given a job it couldn't honestly match, chose a perfect trust score over a fabricated resume.</a:t>
-            </a:r>
-          </a:p>
-          <a:p>
-            <a:pPr>
-              <a:spcAft>
-                <a:spcPts val="1400"/>
-              </a:spcAft>
-            </a:pPr>
-            <a:r>
-              <a:rPr sz="2000" b="0" i="0">
-                <a:solidFill>
-                  <a:srgbClr val="2A2A2A"/>
-                </a:solidFill>
-                <a:latin typeface="Calibri"/>
-              </a:rPr>
-              <a:t>•  Quality is measured, not assumed: an evaluation harness caught a real flaw in our own verifier, and we fixed it using the same discipline.</a:t>
-            </a:r>
-          </a:p>
-          <a:p>
-            <a:pPr>
-              <a:spcAft>
-                <a:spcPts val="1400"/>
-              </a:spcAft>
-            </a:pPr>
-            <a:r>
-              <a:rPr sz="2000" b="0" i="0">
-                <a:solidFill>
-                  <a:srgbClr val="2A2A2A"/>
-                </a:solidFill>
-                <a:latin typeface="Calibri"/>
-              </a:rPr>
-              <a:t>•  This pattern, grounded generation plus independent verification, generalizes well beyond résumés, to any AI-generated content where truthfulness matters.</a:t>
-            </a:r>
-          </a:p>
-        </p:txBody>
-      </p:sp>
-      <p:sp>
-        <p:nvSpPr>
-          <p:cNvPr id="6" name="TextBox 5"/>
+            <a:r>
+              <a:rPr sz="1100" b="0" i="0">
+                <a:solidFill>
+                  <a:srgbClr val="6B6B6B"/>
+                </a:solidFill>
+                <a:latin typeface="Calibri"/>
+              </a:rPr>
+              <a:t>TrustResume | MSAI 699 Capstone Final Presentation</a:t>
+            </a:r>
+          </a:p>
+        </p:txBody>
+      </p:sp>
+      <p:sp>
+        <p:nvSpPr>
+          <p:cNvPr id="7" name="Rounded Rectangle 6"/>
+          <p:cNvSpPr/>
+          <p:nvPr/>
+        </p:nvSpPr>
+        <p:spPr>
+          <a:xfrm>
+            <a:off x="640080" y="1554480"/>
+            <a:ext cx="10908792" cy="1691640"/>
+          </a:xfrm>
+          <a:prstGeom prst="roundRect">
+            <a:avLst>
+              <a:gd name="adj" fmla="val 6000"/>
+            </a:avLst>
+          </a:prstGeom>
+          <a:solidFill>
+            <a:srgbClr val="E9EFF8"/>
+          </a:solidFill>
+          <a:ln w="15875">
+            <a:solidFill>
+              <a:srgbClr val="C7D6EC"/>
+            </a:solidFill>
+          </a:ln>
+          <a:effectLst/>
+        </p:spPr>
+        <p:style>
+          <a:lnRef idx="1">
+            <a:schemeClr val="accent1"/>
+          </a:lnRef>
+          <a:fillRef idx="3">
+            <a:schemeClr val="accent1"/>
+          </a:fillRef>
+          <a:effectRef idx="2">
+            <a:schemeClr val="accent1"/>
+          </a:effectRef>
+          <a:fontRef idx="minor">
+            <a:schemeClr val="lt1"/>
+          </a:fontRef>
+        </p:style>
+        <p:txBody>
+          <a:bodyPr rtlCol="0" anchor="ctr"/>
+          <a:lstStyle/>
+          <a:p>
+            <a:pPr algn="ctr"/>
+          </a:p>
+        </p:txBody>
+      </p:sp>
+      <p:sp>
+        <p:nvSpPr>
+          <p:cNvPr id="8" name="TextBox 7"/>
           <p:cNvSpPr txBox="1"/>
           <p:nvPr/>
         </p:nvSpPr>
         <p:spPr>
           <a:xfrm>
-            <a:off x="640080" y="6446520"/>
-            <a:ext cx="10911535" cy="320040"/>
+            <a:off x="822960" y="1554480"/>
+            <a:ext cx="10543032" cy="1691640"/>
           </a:xfrm>
           <a:prstGeom prst="rect">
             <a:avLst/>
@@ -5272,19 +5654,152 @@
           <a:noFill/>
         </p:spPr>
         <p:txBody>
-          <a:bodyPr wrap="square">
+          <a:bodyPr wrap="square" anchor="ctr" tIns="27432" bIns="27432">
             <a:spAutoFit/>
           </a:bodyPr>
           <a:lstStyle/>
           <a:p>
-            <a:r>
-              <a:rPr sz="1100" b="0" i="0">
-                <a:solidFill>
-                  <a:srgbClr val="6B6B6B"/>
-                </a:solidFill>
-                <a:latin typeface="Calibri"/>
-              </a:rPr>
-              <a:t>TrustResume | MSAI 699 Capstone Final Presentation</a:t>
+            <a:pPr algn="ctr">
+              <a:lnSpc>
+                <a:spcPct val="105000"/>
+              </a:lnSpc>
+            </a:pPr>
+            <a:r>
+              <a:rPr sz="2800" b="1" i="0">
+                <a:solidFill>
+                  <a:srgbClr val="2A2A2A"/>
+                </a:solidFill>
+                <a:latin typeface="Calibri"/>
+              </a:rPr>
+              <a:t>AI-generated content can be useful — without sacrificing trust.</a:t>
+            </a:r>
+          </a:p>
+          <a:p>
+            <a:pPr algn="ctr">
+              <a:lnSpc>
+                <a:spcPct val="105000"/>
+              </a:lnSpc>
+            </a:pPr>
+            <a:r>
+              <a:rPr sz="3000" b="1" i="0">
+                <a:solidFill>
+                  <a:srgbClr val="4C72B0"/>
+                </a:solidFill>
+                <a:latin typeface="Calibri"/>
+              </a:rPr>
+              <a:t>The key is independent verification.</a:t>
+            </a:r>
+          </a:p>
+        </p:txBody>
+      </p:sp>
+      <p:sp>
+        <p:nvSpPr>
+          <p:cNvPr id="9" name="TextBox 8"/>
+          <p:cNvSpPr txBox="1"/>
+          <p:nvPr/>
+        </p:nvSpPr>
+        <p:spPr>
+          <a:xfrm>
+            <a:off x="822960" y="3520440"/>
+            <a:ext cx="10543032" cy="2103120"/>
+          </a:xfrm>
+          <a:prstGeom prst="rect">
+            <a:avLst/>
+          </a:prstGeom>
+          <a:noFill/>
+        </p:spPr>
+        <p:txBody>
+          <a:bodyPr wrap="square" anchor="t" tIns="27432" bIns="27432">
+            <a:spAutoFit/>
+          </a:bodyPr>
+          <a:lstStyle/>
+          <a:p>
+            <a:pPr algn="ctr">
+              <a:lnSpc>
+                <a:spcPct val="105000"/>
+              </a:lnSpc>
+            </a:pPr>
+            <a:r>
+              <a:rPr sz="2000" b="1" i="0">
+                <a:solidFill>
+                  <a:srgbClr val="4F935F"/>
+                </a:solidFill>
+                <a:latin typeface="Calibri"/>
+              </a:rPr>
+              <a:t>✓  </a:t>
+            </a:r>
+            <a:r>
+              <a:rPr sz="2000" b="0" i="0">
+                <a:solidFill>
+                  <a:srgbClr val="2A2A2A"/>
+                </a:solidFill>
+                <a:latin typeface="Calibri"/>
+              </a:rPr>
+              <a:t>Proven on a real model — it chose an honest score over a fabricated resume.</a:t>
+            </a:r>
+          </a:p>
+          <a:p>
+            <a:pPr algn="ctr">
+              <a:lnSpc>
+                <a:spcPct val="105000"/>
+              </a:lnSpc>
+            </a:pPr>
+            <a:r>
+              <a:rPr sz="800" b="0" i="0">
+                <a:solidFill>
+                  <a:srgbClr val="2A2A2A"/>
+                </a:solidFill>
+                <a:latin typeface="Calibri"/>
+              </a:rPr>
+              <a:t/>
+            </a:r>
+          </a:p>
+          <a:p>
+            <a:pPr algn="ctr">
+              <a:lnSpc>
+                <a:spcPct val="105000"/>
+              </a:lnSpc>
+            </a:pPr>
+            <a:r>
+              <a:rPr sz="2000" b="0" i="0">
+                <a:solidFill>
+                  <a:srgbClr val="2A2A2A"/>
+                </a:solidFill>
+                <a:latin typeface="Calibri"/>
+              </a:rPr>
+              <a:t>For candidates: a resume they can stand behind.   For employers: claims they can trust.</a:t>
+            </a:r>
+          </a:p>
+          <a:p>
+            <a:pPr algn="ctr">
+              <a:lnSpc>
+                <a:spcPct val="105000"/>
+              </a:lnSpc>
+            </a:pPr>
+            <a:r>
+              <a:rPr sz="800" b="0" i="0">
+                <a:solidFill>
+                  <a:srgbClr val="2A2A2A"/>
+                </a:solidFill>
+                <a:latin typeface="Calibri"/>
+              </a:rPr>
+              <a:t/>
+            </a:r>
+          </a:p>
+          <a:p>
+            <a:pPr algn="ctr">
+              <a:lnSpc>
+                <a:spcPct val="105000"/>
+              </a:lnSpc>
+            </a:pPr>
+            <a:r>
+              <a:rPr sz="2000" b="0" i="1">
+                <a:solidFill>
+                  <a:srgbClr val="2A2A2A"/>
+                </a:solidFill>
+                <a:latin typeface="Calibri"/>
+              </a:rPr>
+              <a:t>The pattern — grounded generation + independent verification — fits any AI content where truth matters.</a:t>
             </a:r>
           </a:p>
         </p:txBody>
@@ -5554,21 +6069,21 @@
                 </a:solidFill>
                 <a:latin typeface="Calibri"/>
               </a:rPr>
-              <a:t>The Problem: AI Can Write a Resume. Should You Trust It?</a:t>
-            </a:r>
-          </a:p>
-        </p:txBody>
-      </p:sp>
-      <p:sp>
-        <p:nvSpPr>
-          <p:cNvPr id="5" name="TextBox 4"/>
+              <a:t>The Problem — and Why It Matters</a:t>
+            </a:r>
+          </a:p>
+        </p:txBody>
+      </p:sp>
+      <p:sp>
+        <p:nvSpPr>
+          <p:cNvPr id="6" name="TextBox 5"/>
           <p:cNvSpPr txBox="1"/>
           <p:nvPr/>
         </p:nvSpPr>
         <p:spPr>
           <a:xfrm>
-            <a:off x="640080" y="1417320"/>
-            <a:ext cx="10911535" cy="4846320"/>
+            <a:off x="640080" y="6446520"/>
+            <a:ext cx="10911535" cy="320040"/>
           </a:xfrm>
           <a:prstGeom prst="rect">
             <a:avLst/>
@@ -5581,81 +6096,28 @@
           </a:bodyPr>
           <a:lstStyle/>
           <a:p>
-            <a:pPr>
-              <a:spcAft>
-                <a:spcPts val="1400"/>
-              </a:spcAft>
-            </a:pPr>
-            <a:r>
-              <a:rPr sz="2000" b="0" i="0">
-                <a:solidFill>
-                  <a:srgbClr val="2A2A2A"/>
-                </a:solidFill>
-                <a:latin typeface="Calibri"/>
-              </a:rPr>
-              <a:t>•  Generative AI makes it trivial to produce a polished, professional-sounding resume in seconds.</a:t>
-            </a:r>
-          </a:p>
-          <a:p>
-            <a:pPr>
-              <a:spcAft>
-                <a:spcPts val="1400"/>
-              </a:spcAft>
-            </a:pPr>
-            <a:r>
-              <a:rPr sz="2000" b="0" i="0">
-                <a:solidFill>
-                  <a:srgbClr val="2A2A2A"/>
-                </a:solidFill>
-                <a:latin typeface="Calibri"/>
-              </a:rPr>
-              <a:t>•  But nothing stops it from quietly overstating scope, seniority, or a metric the candidate's real background doesn't support.</a:t>
-            </a:r>
-          </a:p>
-          <a:p>
-            <a:pPr>
-              <a:spcAft>
-                <a:spcPts val="1400"/>
-              </a:spcAft>
-            </a:pPr>
-            <a:r>
-              <a:rPr sz="2000" b="0" i="0">
-                <a:solidFill>
-                  <a:srgbClr val="2A2A2A"/>
-                </a:solidFill>
-                <a:latin typeface="Calibri"/>
-              </a:rPr>
-              <a:t>•  That risk lands on everyone: candidates lose credibility, employers make bad hiring decisions, and every legitimate use of AI in hiring gets tainted by the ones that lie.</a:t>
-            </a:r>
-          </a:p>
-          <a:p>
-            <a:pPr>
-              <a:spcAft>
-                <a:spcPts val="1400"/>
-              </a:spcAft>
-            </a:pPr>
-            <a:r>
-              <a:rPr sz="2000" b="0" i="0">
-                <a:solidFill>
-                  <a:srgbClr val="2A2A2A"/>
-                </a:solidFill>
-                <a:latin typeface="Calibri"/>
-              </a:rPr>
-              <a:t>•  The open question this project answers: can an AI system generate a strong resume and prove every claim in it is true?</a:t>
-            </a:r>
-          </a:p>
-        </p:txBody>
-      </p:sp>
-      <p:sp>
-        <p:nvSpPr>
-          <p:cNvPr id="6" name="TextBox 5"/>
+            <a:r>
+              <a:rPr sz="1100" b="0" i="0">
+                <a:solidFill>
+                  <a:srgbClr val="6B6B6B"/>
+                </a:solidFill>
+                <a:latin typeface="Calibri"/>
+              </a:rPr>
+              <a:t>TrustResume | MSAI 699 Capstone Final Presentation</a:t>
+            </a:r>
+          </a:p>
+        </p:txBody>
+      </p:sp>
+      <p:sp>
+        <p:nvSpPr>
+          <p:cNvPr id="7" name="TextBox 6"/>
           <p:cNvSpPr txBox="1"/>
           <p:nvPr/>
         </p:nvSpPr>
         <p:spPr>
           <a:xfrm>
-            <a:off x="640080" y="6446520"/>
-            <a:ext cx="10911535" cy="320040"/>
+            <a:off x="640080" y="1298448"/>
+            <a:ext cx="10908792" cy="1417320"/>
           </a:xfrm>
           <a:prstGeom prst="rect">
             <a:avLst/>
@@ -5663,19 +6125,426 @@
           <a:noFill/>
         </p:spPr>
         <p:txBody>
-          <a:bodyPr wrap="square">
+          <a:bodyPr wrap="square" anchor="t" tIns="27432" bIns="27432">
             <a:spAutoFit/>
           </a:bodyPr>
           <a:lstStyle/>
           <a:p>
-            <a:r>
-              <a:rPr sz="1100" b="0" i="0">
-                <a:solidFill>
-                  <a:srgbClr val="6B6B6B"/>
-                </a:solidFill>
-                <a:latin typeface="Calibri"/>
-              </a:rPr>
-              <a:t>TrustResume | MSAI 699 Capstone Final Presentation</a:t>
+            <a:pPr algn="l">
+              <a:lnSpc>
+                <a:spcPct val="105000"/>
+              </a:lnSpc>
+            </a:pPr>
+            <a:r>
+              <a:rPr sz="2000" b="0" i="0">
+                <a:solidFill>
+                  <a:srgbClr val="2A2A2A"/>
+                </a:solidFill>
+                <a:latin typeface="Calibri"/>
+              </a:rPr>
+              <a:t>•  Generative AI writes a polished resume in seconds — but nothing stops it from overstating scope, seniority, or a metric.</a:t>
+            </a:r>
+          </a:p>
+          <a:p>
+            <a:pPr algn="l">
+              <a:lnSpc>
+                <a:spcPct val="105000"/>
+              </a:lnSpc>
+            </a:pPr>
+            <a:r>
+              <a:rPr sz="2000" b="0" i="0">
+                <a:solidFill>
+                  <a:srgbClr val="2A2A2A"/>
+                </a:solidFill>
+                <a:latin typeface="Calibri"/>
+              </a:rPr>
+              <a:t>•  A fabricated claim looks identical to a real one. There is no built-in way to tell them apart.</a:t>
+            </a:r>
+          </a:p>
+        </p:txBody>
+      </p:sp>
+      <p:sp>
+        <p:nvSpPr>
+          <p:cNvPr id="8" name="TextBox 7"/>
+          <p:cNvSpPr txBox="1"/>
+          <p:nvPr/>
+        </p:nvSpPr>
+        <p:spPr>
+          <a:xfrm>
+            <a:off x="640080" y="2788920"/>
+            <a:ext cx="10908792" cy="457200"/>
+          </a:xfrm>
+          <a:prstGeom prst="rect">
+            <a:avLst/>
+          </a:prstGeom>
+          <a:noFill/>
+        </p:spPr>
+        <p:txBody>
+          <a:bodyPr wrap="square" anchor="t" tIns="27432" bIns="27432">
+            <a:spAutoFit/>
+          </a:bodyPr>
+          <a:lstStyle/>
+          <a:p>
+            <a:pPr algn="l"/>
+            <a:r>
+              <a:rPr sz="2000" b="1" i="0">
+                <a:solidFill>
+                  <a:srgbClr val="DD8452"/>
+                </a:solidFill>
+                <a:latin typeface="Calibri"/>
+              </a:rPr>
+              <a:t>Why it matters — to everyone in hiring:</a:t>
+            </a:r>
+          </a:p>
+        </p:txBody>
+      </p:sp>
+      <p:sp>
+        <p:nvSpPr>
+          <p:cNvPr id="9" name="Rounded Rectangle 8"/>
+          <p:cNvSpPr/>
+          <p:nvPr/>
+        </p:nvSpPr>
+        <p:spPr>
+          <a:xfrm>
+            <a:off x="640080" y="3310128"/>
+            <a:ext cx="3419856" cy="2331720"/>
+          </a:xfrm>
+          <a:prstGeom prst="roundRect">
+            <a:avLst>
+              <a:gd name="adj" fmla="val 6000"/>
+            </a:avLst>
+          </a:prstGeom>
+          <a:solidFill>
+            <a:srgbClr val="E9EFF8"/>
+          </a:solidFill>
+          <a:ln>
+            <a:noFill/>
+          </a:ln>
+          <a:effectLst/>
+        </p:spPr>
+        <p:style>
+          <a:lnRef idx="1">
+            <a:schemeClr val="accent1"/>
+          </a:lnRef>
+          <a:fillRef idx="3">
+            <a:schemeClr val="accent1"/>
+          </a:fillRef>
+          <a:effectRef idx="2">
+            <a:schemeClr val="accent1"/>
+          </a:effectRef>
+          <a:fontRef idx="minor">
+            <a:schemeClr val="lt1"/>
+          </a:fontRef>
+        </p:style>
+        <p:txBody>
+          <a:bodyPr rtlCol="0" anchor="ctr"/>
+          <a:lstStyle/>
+          <a:p>
+            <a:pPr algn="ctr"/>
+          </a:p>
+        </p:txBody>
+      </p:sp>
+      <p:sp>
+        <p:nvSpPr>
+          <p:cNvPr id="10" name="TextBox 9"/>
+          <p:cNvSpPr txBox="1"/>
+          <p:nvPr/>
+        </p:nvSpPr>
+        <p:spPr>
+          <a:xfrm>
+            <a:off x="749808" y="3474720"/>
+            <a:ext cx="3200400" cy="2011680"/>
+          </a:xfrm>
+          <a:prstGeom prst="rect">
+            <a:avLst/>
+          </a:prstGeom>
+          <a:noFill/>
+        </p:spPr>
+        <p:txBody>
+          <a:bodyPr wrap="square" anchor="t" tIns="27432" bIns="27432">
+            <a:spAutoFit/>
+          </a:bodyPr>
+          <a:lstStyle/>
+          <a:p>
+            <a:pPr algn="l">
+              <a:lnSpc>
+                <a:spcPct val="105000"/>
+              </a:lnSpc>
+            </a:pPr>
+            <a:r>
+              <a:rPr sz="2200" b="1" i="0">
+                <a:solidFill>
+                  <a:srgbClr val="4C72B0"/>
+                </a:solidFill>
+                <a:latin typeface="Calibri"/>
+              </a:rPr>
+              <a:t>Candidates</a:t>
+            </a:r>
+          </a:p>
+          <a:p>
+            <a:pPr algn="l">
+              <a:lnSpc>
+                <a:spcPct val="105000"/>
+              </a:lnSpc>
+            </a:pPr>
+            <a:r>
+              <a:rPr sz="600" b="0" i="0">
+                <a:solidFill>
+                  <a:srgbClr val="2A2A2A"/>
+                </a:solidFill>
+                <a:latin typeface="Calibri"/>
+              </a:rPr>
+              <a:t/>
+            </a:r>
+          </a:p>
+          <a:p>
+            <a:pPr algn="l">
+              <a:lnSpc>
+                <a:spcPct val="105000"/>
+              </a:lnSpc>
+            </a:pPr>
+            <a:r>
+              <a:rPr sz="1700" b="0" i="0">
+                <a:solidFill>
+                  <a:srgbClr val="2A2A2A"/>
+                </a:solidFill>
+                <a:latin typeface="Calibri"/>
+              </a:rPr>
+              <a:t>Lose credibility when a claim can’t be backed up.</a:t>
+            </a:r>
+          </a:p>
+        </p:txBody>
+      </p:sp>
+      <p:sp>
+        <p:nvSpPr>
+          <p:cNvPr id="11" name="Rounded Rectangle 10"/>
+          <p:cNvSpPr/>
+          <p:nvPr/>
+        </p:nvSpPr>
+        <p:spPr>
+          <a:xfrm>
+            <a:off x="4384548" y="3310128"/>
+            <a:ext cx="3419856" cy="2331720"/>
+          </a:xfrm>
+          <a:prstGeom prst="roundRect">
+            <a:avLst>
+              <a:gd name="adj" fmla="val 6000"/>
+            </a:avLst>
+          </a:prstGeom>
+          <a:solidFill>
+            <a:srgbClr val="E6F1EA"/>
+          </a:solidFill>
+          <a:ln>
+            <a:noFill/>
+          </a:ln>
+          <a:effectLst/>
+        </p:spPr>
+        <p:style>
+          <a:lnRef idx="1">
+            <a:schemeClr val="accent1"/>
+          </a:lnRef>
+          <a:fillRef idx="3">
+            <a:schemeClr val="accent1"/>
+          </a:fillRef>
+          <a:effectRef idx="2">
+            <a:schemeClr val="accent1"/>
+          </a:effectRef>
+          <a:fontRef idx="minor">
+            <a:schemeClr val="lt1"/>
+          </a:fontRef>
+        </p:style>
+        <p:txBody>
+          <a:bodyPr rtlCol="0" anchor="ctr"/>
+          <a:lstStyle/>
+          <a:p>
+            <a:pPr algn="ctr"/>
+          </a:p>
+        </p:txBody>
+      </p:sp>
+      <p:sp>
+        <p:nvSpPr>
+          <p:cNvPr id="12" name="TextBox 11"/>
+          <p:cNvSpPr txBox="1"/>
+          <p:nvPr/>
+        </p:nvSpPr>
+        <p:spPr>
+          <a:xfrm>
+            <a:off x="4494276" y="3474720"/>
+            <a:ext cx="3200400" cy="2011680"/>
+          </a:xfrm>
+          <a:prstGeom prst="rect">
+            <a:avLst/>
+          </a:prstGeom>
+          <a:noFill/>
+        </p:spPr>
+        <p:txBody>
+          <a:bodyPr wrap="square" anchor="t" tIns="27432" bIns="27432">
+            <a:spAutoFit/>
+          </a:bodyPr>
+          <a:lstStyle/>
+          <a:p>
+            <a:pPr algn="l">
+              <a:lnSpc>
+                <a:spcPct val="105000"/>
+              </a:lnSpc>
+            </a:pPr>
+            <a:r>
+              <a:rPr sz="2200" b="1" i="0">
+                <a:solidFill>
+                  <a:srgbClr val="4F935F"/>
+                </a:solidFill>
+                <a:latin typeface="Calibri"/>
+              </a:rPr>
+              <a:t>Employers</a:t>
+            </a:r>
+          </a:p>
+          <a:p>
+            <a:pPr algn="l">
+              <a:lnSpc>
+                <a:spcPct val="105000"/>
+              </a:lnSpc>
+            </a:pPr>
+            <a:r>
+              <a:rPr sz="600" b="0" i="0">
+                <a:solidFill>
+                  <a:srgbClr val="2A2A2A"/>
+                </a:solidFill>
+                <a:latin typeface="Calibri"/>
+              </a:rPr>
+              <a:t/>
+            </a:r>
+          </a:p>
+          <a:p>
+            <a:pPr algn="l">
+              <a:lnSpc>
+                <a:spcPct val="105000"/>
+              </a:lnSpc>
+            </a:pPr>
+            <a:r>
+              <a:rPr sz="1700" b="0" i="0">
+                <a:solidFill>
+                  <a:srgbClr val="2A2A2A"/>
+                </a:solidFill>
+                <a:latin typeface="Calibri"/>
+              </a:rPr>
+              <a:t>Waste time and money on bad hires.</a:t>
+            </a:r>
+          </a:p>
+        </p:txBody>
+      </p:sp>
+      <p:sp>
+        <p:nvSpPr>
+          <p:cNvPr id="13" name="Rounded Rectangle 12"/>
+          <p:cNvSpPr/>
+          <p:nvPr/>
+        </p:nvSpPr>
+        <p:spPr>
+          <a:xfrm>
+            <a:off x="8129016" y="3310128"/>
+            <a:ext cx="3419856" cy="2331720"/>
+          </a:xfrm>
+          <a:prstGeom prst="roundRect">
+            <a:avLst>
+              <a:gd name="adj" fmla="val 6000"/>
+            </a:avLst>
+          </a:prstGeom>
+          <a:solidFill>
+            <a:srgbClr val="FBEFE6"/>
+          </a:solidFill>
+          <a:ln>
+            <a:noFill/>
+          </a:ln>
+          <a:effectLst/>
+        </p:spPr>
+        <p:style>
+          <a:lnRef idx="1">
+            <a:schemeClr val="accent1"/>
+          </a:lnRef>
+          <a:fillRef idx="3">
+            <a:schemeClr val="accent1"/>
+          </a:fillRef>
+          <a:effectRef idx="2">
+            <a:schemeClr val="accent1"/>
+          </a:effectRef>
+          <a:fontRef idx="minor">
+            <a:schemeClr val="lt1"/>
+          </a:fontRef>
+        </p:style>
+        <p:txBody>
+          <a:bodyPr rtlCol="0" anchor="ctr"/>
+          <a:lstStyle/>
+          <a:p>
+            <a:pPr algn="ctr"/>
+          </a:p>
+        </p:txBody>
+      </p:sp>
+      <p:sp>
+        <p:nvSpPr>
+          <p:cNvPr id="14" name="TextBox 13"/>
+          <p:cNvSpPr txBox="1"/>
+          <p:nvPr/>
+        </p:nvSpPr>
+        <p:spPr>
+          <a:xfrm>
+            <a:off x="8238744" y="3474720"/>
+            <a:ext cx="3200400" cy="2011680"/>
+          </a:xfrm>
+          <a:prstGeom prst="rect">
+            <a:avLst/>
+          </a:prstGeom>
+          <a:noFill/>
+        </p:spPr>
+        <p:txBody>
+          <a:bodyPr wrap="square" anchor="t" tIns="27432" bIns="27432">
+            <a:spAutoFit/>
+          </a:bodyPr>
+          <a:lstStyle/>
+          <a:p>
+            <a:pPr algn="l">
+              <a:lnSpc>
+                <a:spcPct val="105000"/>
+              </a:lnSpc>
+            </a:pPr>
+            <a:r>
+              <a:rPr sz="2200" b="1" i="0">
+                <a:solidFill>
+                  <a:srgbClr val="DD8452"/>
+                </a:solidFill>
+                <a:latin typeface="Calibri"/>
+              </a:rPr>
+              <a:t>Organizations</a:t>
+            </a:r>
+          </a:p>
+          <a:p>
+            <a:pPr algn="l">
+              <a:lnSpc>
+                <a:spcPct val="105000"/>
+              </a:lnSpc>
+            </a:pPr>
+            <a:r>
+              <a:rPr sz="600" b="0" i="0">
+                <a:solidFill>
+                  <a:srgbClr val="2A2A2A"/>
+                </a:solidFill>
+                <a:latin typeface="Calibri"/>
+              </a:rPr>
+              <a:t/>
+            </a:r>
+          </a:p>
+          <a:p>
+            <a:pPr algn="l">
+              <a:lnSpc>
+                <a:spcPct val="105000"/>
+              </a:lnSpc>
+            </a:pPr>
+            <a:r>
+              <a:rPr sz="1700" b="0" i="0">
+                <a:solidFill>
+                  <a:srgbClr val="2A2A2A"/>
+                </a:solidFill>
+                <a:latin typeface="Calibri"/>
+              </a:rPr>
+              <a:t>Face legal &amp; reputational risk from unverifiable AI content.</a:t>
             </a:r>
           </a:p>
         </p:txBody>
@@ -5815,21 +6684,21 @@
                 </a:solidFill>
                 <a:latin typeface="Calibri"/>
               </a:rPr>
-              <a:t>The Solution: Generate, Then Independently Verify</a:t>
-            </a:r>
-          </a:p>
-        </p:txBody>
-      </p:sp>
-      <p:sp>
-        <p:nvSpPr>
-          <p:cNvPr id="5" name="TextBox 4"/>
+              <a:t>The Innovation: Generate First, Verify Independently</a:t>
+            </a:r>
+          </a:p>
+        </p:txBody>
+      </p:sp>
+      <p:sp>
+        <p:nvSpPr>
+          <p:cNvPr id="6" name="TextBox 5"/>
           <p:cNvSpPr txBox="1"/>
           <p:nvPr/>
         </p:nvSpPr>
         <p:spPr>
           <a:xfrm>
-            <a:off x="640080" y="1417320"/>
-            <a:ext cx="10911535" cy="4846320"/>
+            <a:off x="640080" y="6446520"/>
+            <a:ext cx="10911535" cy="320040"/>
           </a:xfrm>
           <a:prstGeom prst="rect">
             <a:avLst/>
@@ -5842,81 +6711,74 @@
           </a:bodyPr>
           <a:lstStyle/>
           <a:p>
-            <a:pPr>
-              <a:spcAft>
-                <a:spcPts val="1400"/>
-              </a:spcAft>
-            </a:pPr>
-            <a:r>
-              <a:rPr sz="2000" b="0" i="0">
-                <a:solidFill>
-                  <a:srgbClr val="2A2A2A"/>
-                </a:solidFill>
-                <a:latin typeface="Calibri"/>
-              </a:rPr>
-              <a:t>•  TrustResume retrieves a candidate's own documents (resumes, project notes, performance reviews) as grounding evidence. This is retrieval-augmented generation (RAG).</a:t>
-            </a:r>
-          </a:p>
-          <a:p>
-            <a:pPr>
-              <a:spcAft>
-                <a:spcPts val="1400"/>
-              </a:spcAft>
-            </a:pPr>
-            <a:r>
-              <a:rPr sz="2000" b="0" i="0">
-                <a:solidFill>
-                  <a:srgbClr val="2A2A2A"/>
-                </a:solidFill>
-                <a:latin typeface="Calibri"/>
-              </a:rPr>
-              <a:t>•  A writer agent drafts the resume from that evidence, but a second, independent agent then checks every claim against it.</a:t>
-            </a:r>
-          </a:p>
-          <a:p>
-            <a:pPr>
-              <a:spcAft>
-                <a:spcPts val="1400"/>
-              </a:spcAft>
-            </a:pPr>
-            <a:r>
-              <a:rPr sz="2000" b="0" i="0">
-                <a:solidFill>
-                  <a:srgbClr val="2A2A2A"/>
-                </a:solidFill>
-                <a:latin typeface="Calibri"/>
-              </a:rPr>
-              <a:t>•  A resume only ships once it's scored against a Trust gate and an ATS keyword-coverage gate; the system always rewrites at least once more, pass or fail, then keeps whichever draft actually scored best.</a:t>
-            </a:r>
-          </a:p>
-          <a:p>
-            <a:pPr>
-              <a:spcAft>
-                <a:spcPts val="1400"/>
-              </a:spcAft>
-            </a:pPr>
-            <a:r>
-              <a:rPr sz="2000" b="0" i="0">
-                <a:solidFill>
-                  <a:srgbClr val="2A2A2A"/>
-                </a:solidFill>
-                <a:latin typeface="Calibri"/>
-              </a:rPr>
-              <a:t>•  The core design bet: the system would rather fail a candidate than lie for them. We'll see that proven with a real example later.</a:t>
-            </a:r>
-          </a:p>
-        </p:txBody>
-      </p:sp>
-      <p:sp>
-        <p:nvSpPr>
-          <p:cNvPr id="6" name="TextBox 5"/>
+            <a:r>
+              <a:rPr sz="1100" b="0" i="0">
+                <a:solidFill>
+                  <a:srgbClr val="6B6B6B"/>
+                </a:solidFill>
+                <a:latin typeface="Calibri"/>
+              </a:rPr>
+              <a:t>TrustResume | MSAI 699 Capstone Final Presentation</a:t>
+            </a:r>
+          </a:p>
+        </p:txBody>
+      </p:sp>
+      <p:sp>
+        <p:nvSpPr>
+          <p:cNvPr id="7" name="Rounded Rectangle 6"/>
+          <p:cNvSpPr/>
+          <p:nvPr/>
+        </p:nvSpPr>
+        <p:spPr>
+          <a:xfrm>
+            <a:off x="640080" y="1298448"/>
+            <a:ext cx="10908792" cy="932688"/>
+          </a:xfrm>
+          <a:prstGeom prst="roundRect">
+            <a:avLst>
+              <a:gd name="adj" fmla="val 6000"/>
+            </a:avLst>
+          </a:prstGeom>
+          <a:solidFill>
+            <a:srgbClr val="FBEFE6"/>
+          </a:solidFill>
+          <a:ln>
+            <a:noFill/>
+          </a:ln>
+          <a:effectLst/>
+        </p:spPr>
+        <p:style>
+          <a:lnRef idx="1">
+            <a:schemeClr val="accent1"/>
+          </a:lnRef>
+          <a:fillRef idx="3">
+            <a:schemeClr val="accent1"/>
+          </a:fillRef>
+          <a:effectRef idx="2">
+            <a:schemeClr val="accent1"/>
+          </a:effectRef>
+          <a:fontRef idx="minor">
+            <a:schemeClr val="lt1"/>
+          </a:fontRef>
+        </p:style>
+        <p:txBody>
+          <a:bodyPr rtlCol="0" anchor="ctr"/>
+          <a:lstStyle/>
+          <a:p>
+            <a:pPr algn="ctr"/>
+          </a:p>
+        </p:txBody>
+      </p:sp>
+      <p:sp>
+        <p:nvSpPr>
+          <p:cNvPr id="8" name="TextBox 7"/>
           <p:cNvSpPr txBox="1"/>
           <p:nvPr/>
         </p:nvSpPr>
         <p:spPr>
           <a:xfrm>
-            <a:off x="640080" y="6446520"/>
-            <a:ext cx="10911535" cy="320040"/>
+            <a:off x="777240" y="1298448"/>
+            <a:ext cx="10634472" cy="932688"/>
           </a:xfrm>
           <a:prstGeom prst="rect">
             <a:avLst/>
@@ -5924,19 +6786,395 @@
           <a:noFill/>
         </p:spPr>
         <p:txBody>
-          <a:bodyPr wrap="square">
+          <a:bodyPr wrap="square" anchor="ctr" tIns="27432" bIns="27432">
             <a:spAutoFit/>
           </a:bodyPr>
           <a:lstStyle/>
           <a:p>
-            <a:r>
-              <a:rPr sz="1100" b="0" i="0">
-                <a:solidFill>
-                  <a:srgbClr val="6B6B6B"/>
-                </a:solidFill>
-                <a:latin typeface="Calibri"/>
-              </a:rPr>
-              <a:t>TrustResume | MSAI 699 Capstone Final Presentation</a:t>
+            <a:pPr algn="ctr">
+              <a:lnSpc>
+                <a:spcPct val="100000"/>
+              </a:lnSpc>
+            </a:pPr>
+            <a:r>
+              <a:rPr sz="2200" b="1" i="0">
+                <a:solidFill>
+                  <a:srgbClr val="2A2A2A"/>
+                </a:solidFill>
+                <a:latin typeface="Calibri"/>
+              </a:rPr>
+              <a:t>Every claim is independently verified against the candidate’s own evidence — before the resume is delivered.</a:t>
+            </a:r>
+          </a:p>
+        </p:txBody>
+      </p:sp>
+      <p:sp>
+        <p:nvSpPr>
+          <p:cNvPr id="9" name="Rounded Rectangle 8"/>
+          <p:cNvSpPr/>
+          <p:nvPr/>
+        </p:nvSpPr>
+        <p:spPr>
+          <a:xfrm>
+            <a:off x="914400" y="2606040"/>
+            <a:ext cx="4160520" cy="1554480"/>
+          </a:xfrm>
+          <a:prstGeom prst="roundRect">
+            <a:avLst>
+              <a:gd name="adj" fmla="val 6000"/>
+            </a:avLst>
+          </a:prstGeom>
+          <a:solidFill>
+            <a:srgbClr val="E9EFF8"/>
+          </a:solidFill>
+          <a:ln>
+            <a:noFill/>
+          </a:ln>
+          <a:effectLst/>
+        </p:spPr>
+        <p:style>
+          <a:lnRef idx="1">
+            <a:schemeClr val="accent1"/>
+          </a:lnRef>
+          <a:fillRef idx="3">
+            <a:schemeClr val="accent1"/>
+          </a:fillRef>
+          <a:effectRef idx="2">
+            <a:schemeClr val="accent1"/>
+          </a:effectRef>
+          <a:fontRef idx="minor">
+            <a:schemeClr val="lt1"/>
+          </a:fontRef>
+        </p:style>
+        <p:txBody>
+          <a:bodyPr rtlCol="0" anchor="ctr"/>
+          <a:lstStyle/>
+          <a:p>
+            <a:pPr algn="ctr"/>
+          </a:p>
+        </p:txBody>
+      </p:sp>
+      <p:sp>
+        <p:nvSpPr>
+          <p:cNvPr id="10" name="TextBox 9"/>
+          <p:cNvSpPr txBox="1"/>
+          <p:nvPr/>
+        </p:nvSpPr>
+        <p:spPr>
+          <a:xfrm>
+            <a:off x="1005840" y="2606040"/>
+            <a:ext cx="3977639" cy="1554480"/>
+          </a:xfrm>
+          <a:prstGeom prst="rect">
+            <a:avLst/>
+          </a:prstGeom>
+          <a:noFill/>
+        </p:spPr>
+        <p:txBody>
+          <a:bodyPr wrap="square" anchor="ctr" tIns="27432" bIns="27432">
+            <a:spAutoFit/>
+          </a:bodyPr>
+          <a:lstStyle/>
+          <a:p>
+            <a:pPr algn="ctr">
+              <a:lnSpc>
+                <a:spcPct val="100000"/>
+              </a:lnSpc>
+            </a:pPr>
+            <a:r>
+              <a:rPr sz="2200" b="1" i="0">
+                <a:solidFill>
+                  <a:srgbClr val="4C72B0"/>
+                </a:solidFill>
+                <a:latin typeface="Calibri"/>
+              </a:rPr>
+              <a:t>Writer Agent</a:t>
+            </a:r>
+          </a:p>
+          <a:p>
+            <a:pPr algn="ctr">
+              <a:lnSpc>
+                <a:spcPct val="100000"/>
+              </a:lnSpc>
+            </a:pPr>
+            <a:r>
+              <a:rPr sz="1700" b="0" i="0">
+                <a:solidFill>
+                  <a:srgbClr val="2A2A2A"/>
+                </a:solidFill>
+                <a:latin typeface="Calibri"/>
+              </a:rPr>
+              <a:t>Generates the resume</a:t>
+            </a:r>
+          </a:p>
+        </p:txBody>
+      </p:sp>
+      <p:sp>
+        <p:nvSpPr>
+          <p:cNvPr id="11" name="Right Arrow 10"/>
+          <p:cNvSpPr/>
+          <p:nvPr/>
+        </p:nvSpPr>
+        <p:spPr>
+          <a:xfrm>
+            <a:off x="5230368" y="3127248"/>
+            <a:ext cx="914400" cy="530352"/>
+          </a:xfrm>
+          <a:prstGeom prst="rightArrow">
+            <a:avLst/>
+          </a:prstGeom>
+          <a:solidFill>
+            <a:srgbClr val="DD8452"/>
+          </a:solidFill>
+          <a:ln>
+            <a:noFill/>
+          </a:ln>
+          <a:effectLst/>
+        </p:spPr>
+        <p:style>
+          <a:lnRef idx="1">
+            <a:schemeClr val="accent1"/>
+          </a:lnRef>
+          <a:fillRef idx="3">
+            <a:schemeClr val="accent1"/>
+          </a:fillRef>
+          <a:effectRef idx="2">
+            <a:schemeClr val="accent1"/>
+          </a:effectRef>
+          <a:fontRef idx="minor">
+            <a:schemeClr val="lt1"/>
+          </a:fontRef>
+        </p:style>
+        <p:txBody>
+          <a:bodyPr rtlCol="0" anchor="ctr"/>
+          <a:lstStyle/>
+          <a:p>
+            <a:pPr algn="ctr"/>
+          </a:p>
+        </p:txBody>
+      </p:sp>
+      <p:sp>
+        <p:nvSpPr>
+          <p:cNvPr id="12" name="Rounded Rectangle 11"/>
+          <p:cNvSpPr/>
+          <p:nvPr/>
+        </p:nvSpPr>
+        <p:spPr>
+          <a:xfrm>
+            <a:off x="6309360" y="2606040"/>
+            <a:ext cx="4965192" cy="1554480"/>
+          </a:xfrm>
+          <a:prstGeom prst="roundRect">
+            <a:avLst>
+              <a:gd name="adj" fmla="val 6000"/>
+            </a:avLst>
+          </a:prstGeom>
+          <a:solidFill>
+            <a:srgbClr val="E6F1EA"/>
+          </a:solidFill>
+          <a:ln>
+            <a:noFill/>
+          </a:ln>
+          <a:effectLst/>
+        </p:spPr>
+        <p:style>
+          <a:lnRef idx="1">
+            <a:schemeClr val="accent1"/>
+          </a:lnRef>
+          <a:fillRef idx="3">
+            <a:schemeClr val="accent1"/>
+          </a:fillRef>
+          <a:effectRef idx="2">
+            <a:schemeClr val="accent1"/>
+          </a:effectRef>
+          <a:fontRef idx="minor">
+            <a:schemeClr val="lt1"/>
+          </a:fontRef>
+        </p:style>
+        <p:txBody>
+          <a:bodyPr rtlCol="0" anchor="ctr"/>
+          <a:lstStyle/>
+          <a:p>
+            <a:pPr algn="ctr"/>
+          </a:p>
+        </p:txBody>
+      </p:sp>
+      <p:sp>
+        <p:nvSpPr>
+          <p:cNvPr id="13" name="TextBox 12"/>
+          <p:cNvSpPr txBox="1"/>
+          <p:nvPr/>
+        </p:nvSpPr>
+        <p:spPr>
+          <a:xfrm>
+            <a:off x="6400800" y="2606040"/>
+            <a:ext cx="4782312" cy="1554480"/>
+          </a:xfrm>
+          <a:prstGeom prst="rect">
+            <a:avLst/>
+          </a:prstGeom>
+          <a:noFill/>
+        </p:spPr>
+        <p:txBody>
+          <a:bodyPr wrap="square" anchor="ctr" tIns="27432" bIns="27432">
+            <a:spAutoFit/>
+          </a:bodyPr>
+          <a:lstStyle/>
+          <a:p>
+            <a:pPr algn="ctr">
+              <a:lnSpc>
+                <a:spcPct val="100000"/>
+              </a:lnSpc>
+            </a:pPr>
+            <a:r>
+              <a:rPr sz="2200" b="1" i="0">
+                <a:solidFill>
+                  <a:srgbClr val="4F935F"/>
+                </a:solidFill>
+                <a:latin typeface="Calibri"/>
+              </a:rPr>
+              <a:t>Independent Verifier</a:t>
+            </a:r>
+          </a:p>
+          <a:p>
+            <a:pPr algn="ctr">
+              <a:lnSpc>
+                <a:spcPct val="100000"/>
+              </a:lnSpc>
+            </a:pPr>
+            <a:r>
+              <a:rPr sz="1700" b="0" i="0">
+                <a:solidFill>
+                  <a:srgbClr val="2A2A2A"/>
+                </a:solidFill>
+                <a:latin typeface="Calibri"/>
+              </a:rPr>
+              <a:t>Checks every claim against the evidence</a:t>
+            </a:r>
+          </a:p>
+        </p:txBody>
+      </p:sp>
+      <p:sp>
+        <p:nvSpPr>
+          <p:cNvPr id="14" name="TextBox 13"/>
+          <p:cNvSpPr txBox="1"/>
+          <p:nvPr/>
+        </p:nvSpPr>
+        <p:spPr>
+          <a:xfrm>
+            <a:off x="640080" y="4389120"/>
+            <a:ext cx="10908792" cy="640080"/>
+          </a:xfrm>
+          <a:prstGeom prst="rect">
+            <a:avLst/>
+          </a:prstGeom>
+          <a:noFill/>
+        </p:spPr>
+        <p:txBody>
+          <a:bodyPr wrap="square" anchor="ctr" tIns="27432" bIns="27432">
+            <a:spAutoFit/>
+          </a:bodyPr>
+          <a:lstStyle/>
+          <a:p>
+            <a:pPr algn="ctr"/>
+            <a:r>
+              <a:rPr sz="2400" b="1" i="0">
+                <a:solidFill>
+                  <a:srgbClr val="C44E52"/>
+                </a:solidFill>
+                <a:latin typeface="Calibri"/>
+              </a:rPr>
+              <a:t>✗  </a:t>
+            </a:r>
+            <a:r>
+              <a:rPr sz="2400" b="1" i="0">
+                <a:solidFill>
+                  <a:srgbClr val="2A2A2A"/>
+                </a:solidFill>
+                <a:latin typeface="Calibri"/>
+              </a:rPr>
+              <a:t>The Writer never verifies its own claims.</a:t>
+            </a:r>
+          </a:p>
+        </p:txBody>
+      </p:sp>
+      <p:sp>
+        <p:nvSpPr>
+          <p:cNvPr id="15" name="Rounded Rectangle 14"/>
+          <p:cNvSpPr/>
+          <p:nvPr/>
+        </p:nvSpPr>
+        <p:spPr>
+          <a:xfrm>
+            <a:off x="3712463" y="5138928"/>
+            <a:ext cx="4754880" cy="566928"/>
+          </a:xfrm>
+          <a:prstGeom prst="roundRect">
+            <a:avLst>
+              <a:gd name="adj" fmla="val 6000"/>
+            </a:avLst>
+          </a:prstGeom>
+          <a:solidFill>
+            <a:srgbClr val="DD8452"/>
+          </a:solidFill>
+          <a:ln>
+            <a:noFill/>
+          </a:ln>
+          <a:effectLst/>
+        </p:spPr>
+        <p:style>
+          <a:lnRef idx="1">
+            <a:schemeClr val="accent1"/>
+          </a:lnRef>
+          <a:fillRef idx="3">
+            <a:schemeClr val="accent1"/>
+          </a:fillRef>
+          <a:effectRef idx="2">
+            <a:schemeClr val="accent1"/>
+          </a:effectRef>
+          <a:fontRef idx="minor">
+            <a:schemeClr val="lt1"/>
+          </a:fontRef>
+        </p:style>
+        <p:txBody>
+          <a:bodyPr rtlCol="0" anchor="ctr"/>
+          <a:lstStyle/>
+          <a:p>
+            <a:pPr algn="ctr"/>
+          </a:p>
+        </p:txBody>
+      </p:sp>
+      <p:sp>
+        <p:nvSpPr>
+          <p:cNvPr id="16" name="TextBox 15"/>
+          <p:cNvSpPr txBox="1"/>
+          <p:nvPr/>
+        </p:nvSpPr>
+        <p:spPr>
+          <a:xfrm>
+            <a:off x="3712463" y="5138928"/>
+            <a:ext cx="4754880" cy="566928"/>
+          </a:xfrm>
+          <a:prstGeom prst="rect">
+            <a:avLst/>
+          </a:prstGeom>
+          <a:noFill/>
+        </p:spPr>
+        <p:txBody>
+          <a:bodyPr wrap="square" anchor="ctr" tIns="27432" bIns="27432">
+            <a:spAutoFit/>
+          </a:bodyPr>
+          <a:lstStyle/>
+          <a:p>
+            <a:pPr algn="ctr"/>
+            <a:r>
+              <a:rPr sz="1800" b="1" i="0">
+                <a:solidFill>
+                  <a:srgbClr val="FFFFFF"/>
+                </a:solidFill>
+                <a:latin typeface="Calibri"/>
+              </a:rPr>
+              <a:t>Independent Verification Layer</a:t>
             </a:r>
           </a:p>
         </p:txBody>
@@ -6135,7 +7373,7 @@
                 </a:solidFill>
                 <a:latin typeface="Calibri"/>
               </a:rPr>
-              <a:t>Job Description → Evidence Retrieval → Resume Writer ↔ Trust Harness / ATS Evaluation, with a cached Candidate Profile feeding the writer.</a:t>
+              <a:t>The Writer drafts, the Verifier and an ATS check score it, the system rewrites — then keeps the best-scoring draft.</a:t>
             </a:r>
           </a:p>
         </p:txBody>
@@ -6309,21 +7547,21 @@
                 </a:solidFill>
                 <a:latin typeface="Calibri"/>
               </a:rPr>
-              <a:t>Built for Reliability, Not Just a Demo</a:t>
-            </a:r>
-          </a:p>
-        </p:txBody>
-      </p:sp>
-      <p:sp>
-        <p:nvSpPr>
-          <p:cNvPr id="5" name="TextBox 4"/>
+              <a:t>System Architecture: How the Pieces Fit</a:t>
+            </a:r>
+          </a:p>
+        </p:txBody>
+      </p:sp>
+      <p:sp>
+        <p:nvSpPr>
+          <p:cNvPr id="6" name="TextBox 5"/>
           <p:cNvSpPr txBox="1"/>
           <p:nvPr/>
         </p:nvSpPr>
         <p:spPr>
           <a:xfrm>
-            <a:off x="640080" y="1417320"/>
-            <a:ext cx="10911535" cy="4846320"/>
+            <a:off x="640080" y="6446520"/>
+            <a:ext cx="10911535" cy="320040"/>
           </a:xfrm>
           <a:prstGeom prst="rect">
             <a:avLst/>
@@ -6336,121 +7574,42 @@
           </a:bodyPr>
           <a:lstStyle/>
           <a:p>
-            <a:pPr>
-              <a:spcAft>
-                <a:spcPts val="1400"/>
-              </a:spcAft>
-            </a:pPr>
-            <a:r>
-              <a:rPr sz="2000" b="0" i="0">
-                <a:solidFill>
-                  <a:srgbClr val="2A2A2A"/>
-                </a:solidFill>
-                <a:latin typeface="Calibri"/>
-              </a:rPr>
-              <a:t>•  LangChain + LangGraph orchestrate every agent and the rewrite loop; ChromaDB + SQLite/FTS5 power hybrid retrieval.</a:t>
-            </a:r>
-          </a:p>
-          <a:p>
-            <a:pPr>
-              <a:spcAft>
-                <a:spcPts val="1400"/>
-              </a:spcAft>
-            </a:pPr>
-            <a:r>
-              <a:rPr sz="2000" b="0" i="0">
-                <a:solidFill>
-                  <a:srgbClr val="2A2A2A"/>
-                </a:solidFill>
-                <a:latin typeface="Calibri"/>
-              </a:rPr>
-              <a:t>•  Works with AWS Bedrock, OpenAI, or Google: the LLM provider is a configuration choice, not a code change.</a:t>
-            </a:r>
-          </a:p>
-          <a:p>
-            <a:pPr>
-              <a:spcAft>
-                <a:spcPts val="1400"/>
-              </a:spcAft>
-            </a:pPr>
-            <a:r>
-              <a:rPr sz="2000" b="0" i="0">
-                <a:solidFill>
-                  <a:srgbClr val="2A2A2A"/>
-                </a:solidFill>
-                <a:latin typeface="Calibri"/>
-              </a:rPr>
-              <a:t>•  Sampling temperature is pinned to zero: the Trust score is a deterministic, code-computed number, not a re-roll of the dice.</a:t>
-            </a:r>
-          </a:p>
-          <a:p>
-            <a:pPr>
-              <a:spcAft>
-                <a:spcPts val="1400"/>
-              </a:spcAft>
-            </a:pPr>
-            <a:r>
-              <a:rPr sz="2000" b="0" i="0">
-                <a:solidFill>
-                  <a:srgbClr val="2A2A2A"/>
-                </a:solidFill>
-                <a:latin typeface="Calibri"/>
-              </a:rPr>
-              <a:t>•  Models are tiered by role: a cheap model fills a form, a stronger one only where it changes what a candidate reads or what gets verified.</a:t>
-            </a:r>
-          </a:p>
-          <a:p>
-            <a:pPr>
-              <a:spcAft>
-                <a:spcPts val="1400"/>
-              </a:spcAft>
-            </a:pPr>
-            <a:r>
-              <a:rPr sz="2000" b="0" i="0">
-                <a:solidFill>
-                  <a:srgbClr val="2A2A2A"/>
-                </a:solidFill>
-                <a:latin typeface="Calibri"/>
-              </a:rPr>
-              <a:t>•  Every request is scoped to a specific user's own data: the isolation boundary this whole system depends on.</a:t>
-            </a:r>
-          </a:p>
-        </p:txBody>
-      </p:sp>
-      <p:sp>
-        <p:nvSpPr>
-          <p:cNvPr id="6" name="TextBox 5"/>
-          <p:cNvSpPr txBox="1"/>
+            <a:r>
+              <a:rPr sz="1100" b="0" i="0">
+                <a:solidFill>
+                  <a:srgbClr val="6B6B6B"/>
+                </a:solidFill>
+                <a:latin typeface="Calibri"/>
+              </a:rPr>
+              <a:t>TrustResume | MSAI 699 Capstone Final Presentation</a:t>
+            </a:r>
+          </a:p>
+        </p:txBody>
+      </p:sp>
+      <p:pic>
+        <p:nvPicPr>
+          <p:cNvPr id="7" name="Picture 6" descr="01_system_overview.png"/>
+          <p:cNvPicPr>
+            <a:picLocks noChangeAspect="1"/>
+          </p:cNvPicPr>
           <p:nvPr/>
-        </p:nvSpPr>
-        <p:spPr>
-          <a:xfrm>
-            <a:off x="640080" y="6446520"/>
-            <a:ext cx="10911535" cy="320040"/>
+        </p:nvPicPr>
+        <p:blipFill>
+          <a:blip r:embed="rId3"/>
+          <a:stretch>
+            <a:fillRect/>
+          </a:stretch>
+        </p:blipFill>
+        <p:spPr>
+          <a:xfrm>
+            <a:off x="2900316" y="1371600"/>
+            <a:ext cx="6391063" cy="4892040"/>
           </a:xfrm>
           <a:prstGeom prst="rect">
             <a:avLst/>
           </a:prstGeom>
-          <a:noFill/>
-        </p:spPr>
-        <p:txBody>
-          <a:bodyPr wrap="square">
-            <a:spAutoFit/>
-          </a:bodyPr>
-          <a:lstStyle/>
-          <a:p>
-            <a:r>
-              <a:rPr sz="1100" b="0" i="0">
-                <a:solidFill>
-                  <a:srgbClr val="6B6B6B"/>
-                </a:solidFill>
-                <a:latin typeface="Calibri"/>
-              </a:rPr>
-              <a:t>TrustResume | MSAI 699 Capstone Final Presentation</a:t>
-            </a:r>
-          </a:p>
-        </p:txBody>
-      </p:sp>
+        </p:spPr>
+      </p:pic>
     </p:spTree>
   </p:cSld>
   <p:clrMapOvr>
@@ -6847,45 +8006,21 @@
                 </a:solidFill>
                 <a:latin typeface="Calibri"/>
               </a:rPr>
-              <a:t>The Numbers: Retrieval Finds It, Verification Catches It</a:t>
-            </a:r>
-          </a:p>
-        </p:txBody>
-      </p:sp>
-      <p:pic>
-        <p:nvPicPr>
-          <p:cNvPr id="5" name="Picture 4" descr="fig2_results.png"/>
-          <p:cNvPicPr>
-            <a:picLocks noChangeAspect="1"/>
-          </p:cNvPicPr>
-          <p:nvPr/>
-        </p:nvPicPr>
-        <p:blipFill>
-          <a:blip r:embed="rId2"/>
-          <a:stretch>
-            <a:fillRect/>
-          </a:stretch>
-        </p:blipFill>
-        <p:spPr>
-          <a:xfrm>
-            <a:off x="1295247" y="1325880"/>
-            <a:ext cx="9601200" cy="3200400"/>
-          </a:xfrm>
-          <a:prstGeom prst="rect">
-            <a:avLst/>
-          </a:prstGeom>
-        </p:spPr>
-      </p:pic>
-      <p:sp>
-        <p:nvSpPr>
-          <p:cNvPr id="6" name="TextBox 5"/>
+              <a:t>Results: Measured, Not Assumed</a:t>
+            </a:r>
+          </a:p>
+        </p:txBody>
+      </p:sp>
+      <p:sp>
+        <p:nvSpPr>
+          <p:cNvPr id="7" name="TextBox 6"/>
           <p:cNvSpPr txBox="1"/>
           <p:nvPr/>
         </p:nvSpPr>
         <p:spPr>
           <a:xfrm>
-            <a:off x="640080" y="4617720"/>
-            <a:ext cx="10911535" cy="457200"/>
+            <a:off x="640080" y="6446520"/>
+            <a:ext cx="10911535" cy="320040"/>
           </a:xfrm>
           <a:prstGeom prst="rect">
             <a:avLst/>
@@ -6898,29 +8033,76 @@
           </a:bodyPr>
           <a:lstStyle/>
           <a:p>
+            <a:r>
+              <a:rPr sz="1100" b="0" i="0">
+                <a:solidFill>
+                  <a:srgbClr val="6B6B6B"/>
+                </a:solidFill>
+                <a:latin typeface="Calibri"/>
+              </a:rPr>
+              <a:t>TrustResume | MSAI 699 Capstone Final Presentation</a:t>
+            </a:r>
+          </a:p>
+        </p:txBody>
+      </p:sp>
+      <p:sp>
+        <p:nvSpPr>
+          <p:cNvPr id="8" name="Rounded Rectangle 7"/>
+          <p:cNvSpPr/>
+          <p:nvPr/>
+        </p:nvSpPr>
+        <p:spPr>
+          <a:xfrm>
+            <a:off x="640080" y="1691640"/>
+            <a:ext cx="3419856" cy="2468880"/>
+          </a:xfrm>
+          <a:prstGeom prst="roundRect">
+            <a:avLst>
+              <a:gd name="adj" fmla="val 6000"/>
+            </a:avLst>
+          </a:prstGeom>
+          <a:solidFill>
+            <a:srgbClr val="E9EFF8"/>
+          </a:solidFill>
+          <a:ln w="15875">
+            <a:solidFill>
+              <a:srgbClr val="C7D6EC"/>
+            </a:solidFill>
+          </a:ln>
+          <a:effectLst/>
+        </p:spPr>
+        <p:style>
+          <a:lnRef idx="1">
+            <a:schemeClr val="accent1"/>
+          </a:lnRef>
+          <a:fillRef idx="3">
+            <a:schemeClr val="accent1"/>
+          </a:fillRef>
+          <a:effectRef idx="2">
+            <a:schemeClr val="accent1"/>
+          </a:effectRef>
+          <a:fontRef idx="minor">
+            <a:schemeClr val="lt1"/>
+          </a:fontRef>
+        </p:style>
+        <p:txBody>
+          <a:bodyPr rtlCol="0" anchor="ctr"/>
+          <a:lstStyle/>
+          <a:p>
             <a:pPr algn="ctr"/>
-            <a:r>
-              <a:rPr sz="1400" b="0" i="1">
-                <a:solidFill>
-                  <a:srgbClr val="6B6B6B"/>
-                </a:solidFill>
-                <a:latin typeface="Calibri"/>
-              </a:rPr>
-              <a:t>Left: Trust Harness accuracy before/after a calibration fix. Right: Trust/ATS scores from four real generations against a production model.</a:t>
-            </a:r>
-          </a:p>
-        </p:txBody>
-      </p:sp>
-      <p:sp>
-        <p:nvSpPr>
-          <p:cNvPr id="7" name="TextBox 6"/>
+          </a:p>
+        </p:txBody>
+      </p:sp>
+      <p:sp>
+        <p:nvSpPr>
+          <p:cNvPr id="9" name="TextBox 8"/>
           <p:cNvSpPr txBox="1"/>
           <p:nvPr/>
         </p:nvSpPr>
         <p:spPr>
           <a:xfrm>
-            <a:off x="640080" y="6446520"/>
-            <a:ext cx="10911535" cy="320040"/>
+            <a:off x="731519" y="1783080"/>
+            <a:ext cx="3236976" cy="2286000"/>
           </a:xfrm>
           <a:prstGeom prst="rect">
             <a:avLst/>
@@ -6928,19 +8110,443 @@
           <a:noFill/>
         </p:spPr>
         <p:txBody>
-          <a:bodyPr wrap="square">
+          <a:bodyPr wrap="square" anchor="ctr" tIns="27432" bIns="27432">
             <a:spAutoFit/>
           </a:bodyPr>
           <a:lstStyle/>
           <a:p>
-            <a:r>
-              <a:rPr sz="1100" b="0" i="0">
+            <a:pPr algn="ctr">
+              <a:lnSpc>
+                <a:spcPct val="100000"/>
+              </a:lnSpc>
+            </a:pPr>
+            <a:r>
+              <a:rPr sz="6000" b="1" i="0">
+                <a:solidFill>
+                  <a:srgbClr val="4F935F"/>
+                </a:solidFill>
+                <a:latin typeface="Calibri"/>
+              </a:rPr>
+              <a:t>100%</a:t>
+            </a:r>
+          </a:p>
+          <a:p>
+            <a:pPr algn="ctr">
+              <a:lnSpc>
+                <a:spcPct val="100000"/>
+              </a:lnSpc>
+            </a:pPr>
+            <a:r>
+              <a:rPr sz="1800" b="1" i="0">
+                <a:solidFill>
+                  <a:srgbClr val="2A2A2A"/>
+                </a:solidFill>
+                <a:latin typeface="Calibri"/>
+              </a:rPr>
+              <a:t>Retrieval Recall@8</a:t>
+            </a:r>
+          </a:p>
+          <a:p>
+            <a:pPr algn="ctr">
+              <a:lnSpc>
+                <a:spcPct val="100000"/>
+              </a:lnSpc>
+            </a:pPr>
+            <a:r>
+              <a:rPr sz="400" b="0" i="0">
+                <a:solidFill>
+                  <a:srgbClr val="2A2A2A"/>
+                </a:solidFill>
+                <a:latin typeface="Calibri"/>
+              </a:rPr>
+              <a:t/>
+            </a:r>
+          </a:p>
+          <a:p>
+            <a:pPr algn="ctr">
+              <a:lnSpc>
+                <a:spcPct val="100000"/>
+              </a:lnSpc>
+            </a:pPr>
+            <a:r>
+              <a:rPr sz="1400" b="0" i="0">
                 <a:solidFill>
                   <a:srgbClr val="6B6B6B"/>
                 </a:solidFill>
                 <a:latin typeface="Calibri"/>
               </a:rPr>
-              <a:t>TrustResume | MSAI 699 Capstone Final Presentation</a:t>
+              <a:t>Finds the right evidence, every time</a:t>
+            </a:r>
+          </a:p>
+        </p:txBody>
+      </p:sp>
+      <p:sp>
+        <p:nvSpPr>
+          <p:cNvPr id="10" name="Rounded Rectangle 9"/>
+          <p:cNvSpPr/>
+          <p:nvPr/>
+        </p:nvSpPr>
+        <p:spPr>
+          <a:xfrm>
+            <a:off x="4384548" y="1691640"/>
+            <a:ext cx="3419856" cy="2468880"/>
+          </a:xfrm>
+          <a:prstGeom prst="roundRect">
+            <a:avLst>
+              <a:gd name="adj" fmla="val 6000"/>
+            </a:avLst>
+          </a:prstGeom>
+          <a:solidFill>
+            <a:srgbClr val="E9EFF8"/>
+          </a:solidFill>
+          <a:ln w="15875">
+            <a:solidFill>
+              <a:srgbClr val="C7D6EC"/>
+            </a:solidFill>
+          </a:ln>
+          <a:effectLst/>
+        </p:spPr>
+        <p:style>
+          <a:lnRef idx="1">
+            <a:schemeClr val="accent1"/>
+          </a:lnRef>
+          <a:fillRef idx="3">
+            <a:schemeClr val="accent1"/>
+          </a:fillRef>
+          <a:effectRef idx="2">
+            <a:schemeClr val="accent1"/>
+          </a:effectRef>
+          <a:fontRef idx="minor">
+            <a:schemeClr val="lt1"/>
+          </a:fontRef>
+        </p:style>
+        <p:txBody>
+          <a:bodyPr rtlCol="0" anchor="ctr"/>
+          <a:lstStyle/>
+          <a:p>
+            <a:pPr algn="ctr"/>
+          </a:p>
+        </p:txBody>
+      </p:sp>
+      <p:sp>
+        <p:nvSpPr>
+          <p:cNvPr id="11" name="TextBox 10"/>
+          <p:cNvSpPr txBox="1"/>
+          <p:nvPr/>
+        </p:nvSpPr>
+        <p:spPr>
+          <a:xfrm>
+            <a:off x="4475988" y="1783080"/>
+            <a:ext cx="3236976" cy="2286000"/>
+          </a:xfrm>
+          <a:prstGeom prst="rect">
+            <a:avLst/>
+          </a:prstGeom>
+          <a:noFill/>
+        </p:spPr>
+        <p:txBody>
+          <a:bodyPr wrap="square" anchor="ctr" tIns="27432" bIns="27432">
+            <a:spAutoFit/>
+          </a:bodyPr>
+          <a:lstStyle/>
+          <a:p>
+            <a:pPr algn="ctr">
+              <a:lnSpc>
+                <a:spcPct val="100000"/>
+              </a:lnSpc>
+            </a:pPr>
+            <a:r>
+              <a:rPr sz="6000" b="1" i="0">
+                <a:solidFill>
+                  <a:srgbClr val="4C72B0"/>
+                </a:solidFill>
+                <a:latin typeface="Calibri"/>
+              </a:rPr>
+              <a:t>83.3%</a:t>
+            </a:r>
+          </a:p>
+          <a:p>
+            <a:pPr algn="ctr">
+              <a:lnSpc>
+                <a:spcPct val="100000"/>
+              </a:lnSpc>
+            </a:pPr>
+            <a:r>
+              <a:rPr sz="1800" b="1" i="0">
+                <a:solidFill>
+                  <a:srgbClr val="2A2A2A"/>
+                </a:solidFill>
+                <a:latin typeface="Calibri"/>
+              </a:rPr>
+              <a:t>Trust Harness Accuracy</a:t>
+            </a:r>
+          </a:p>
+          <a:p>
+            <a:pPr algn="ctr">
+              <a:lnSpc>
+                <a:spcPct val="100000"/>
+              </a:lnSpc>
+            </a:pPr>
+            <a:r>
+              <a:rPr sz="400" b="0" i="0">
+                <a:solidFill>
+                  <a:srgbClr val="2A2A2A"/>
+                </a:solidFill>
+                <a:latin typeface="Calibri"/>
+              </a:rPr>
+              <a:t/>
+            </a:r>
+          </a:p>
+          <a:p>
+            <a:pPr algn="ctr">
+              <a:lnSpc>
+                <a:spcPct val="100000"/>
+              </a:lnSpc>
+            </a:pPr>
+            <a:r>
+              <a:rPr sz="1400" b="0" i="0">
+                <a:solidFill>
+                  <a:srgbClr val="6B6B6B"/>
+                </a:solidFill>
+                <a:latin typeface="Calibri"/>
+              </a:rPr>
+              <a:t>Up from 50% after we fixed the rules</a:t>
+            </a:r>
+          </a:p>
+        </p:txBody>
+      </p:sp>
+      <p:sp>
+        <p:nvSpPr>
+          <p:cNvPr id="12" name="Rounded Rectangle 11"/>
+          <p:cNvSpPr/>
+          <p:nvPr/>
+        </p:nvSpPr>
+        <p:spPr>
+          <a:xfrm>
+            <a:off x="8129016" y="1691640"/>
+            <a:ext cx="3419856" cy="2468880"/>
+          </a:xfrm>
+          <a:prstGeom prst="roundRect">
+            <a:avLst>
+              <a:gd name="adj" fmla="val 6000"/>
+            </a:avLst>
+          </a:prstGeom>
+          <a:solidFill>
+            <a:srgbClr val="E9EFF8"/>
+          </a:solidFill>
+          <a:ln w="15875">
+            <a:solidFill>
+              <a:srgbClr val="C7D6EC"/>
+            </a:solidFill>
+          </a:ln>
+          <a:effectLst/>
+        </p:spPr>
+        <p:style>
+          <a:lnRef idx="1">
+            <a:schemeClr val="accent1"/>
+          </a:lnRef>
+          <a:fillRef idx="3">
+            <a:schemeClr val="accent1"/>
+          </a:fillRef>
+          <a:effectRef idx="2">
+            <a:schemeClr val="accent1"/>
+          </a:effectRef>
+          <a:fontRef idx="minor">
+            <a:schemeClr val="lt1"/>
+          </a:fontRef>
+        </p:style>
+        <p:txBody>
+          <a:bodyPr rtlCol="0" anchor="ctr"/>
+          <a:lstStyle/>
+          <a:p>
+            <a:pPr algn="ctr"/>
+          </a:p>
+        </p:txBody>
+      </p:sp>
+      <p:sp>
+        <p:nvSpPr>
+          <p:cNvPr id="13" name="TextBox 12"/>
+          <p:cNvSpPr txBox="1"/>
+          <p:nvPr/>
+        </p:nvSpPr>
+        <p:spPr>
+          <a:xfrm>
+            <a:off x="8220456" y="1783080"/>
+            <a:ext cx="3236976" cy="2286000"/>
+          </a:xfrm>
+          <a:prstGeom prst="rect">
+            <a:avLst/>
+          </a:prstGeom>
+          <a:noFill/>
+        </p:spPr>
+        <p:txBody>
+          <a:bodyPr wrap="square" anchor="ctr" tIns="27432" bIns="27432">
+            <a:spAutoFit/>
+          </a:bodyPr>
+          <a:lstStyle/>
+          <a:p>
+            <a:pPr algn="ctr">
+              <a:lnSpc>
+                <a:spcPct val="100000"/>
+              </a:lnSpc>
+            </a:pPr>
+            <a:r>
+              <a:rPr sz="6000" b="1" i="0">
+                <a:solidFill>
+                  <a:srgbClr val="DD8452"/>
+                </a:solidFill>
+                <a:latin typeface="Calibri"/>
+              </a:rPr>
+              <a:t>99.2%</a:t>
+            </a:r>
+          </a:p>
+          <a:p>
+            <a:pPr algn="ctr">
+              <a:lnSpc>
+                <a:spcPct val="100000"/>
+              </a:lnSpc>
+            </a:pPr>
+            <a:r>
+              <a:rPr sz="1800" b="1" i="0">
+                <a:solidFill>
+                  <a:srgbClr val="2A2A2A"/>
+                </a:solidFill>
+                <a:latin typeface="Calibri"/>
+              </a:rPr>
+              <a:t>Test Coverage</a:t>
+            </a:r>
+          </a:p>
+          <a:p>
+            <a:pPr algn="ctr">
+              <a:lnSpc>
+                <a:spcPct val="100000"/>
+              </a:lnSpc>
+            </a:pPr>
+            <a:r>
+              <a:rPr sz="400" b="0" i="0">
+                <a:solidFill>
+                  <a:srgbClr val="2A2A2A"/>
+                </a:solidFill>
+                <a:latin typeface="Calibri"/>
+              </a:rPr>
+              <a:t/>
+            </a:r>
+          </a:p>
+          <a:p>
+            <a:pPr algn="ctr">
+              <a:lnSpc>
+                <a:spcPct val="100000"/>
+              </a:lnSpc>
+            </a:pPr>
+            <a:r>
+              <a:rPr sz="1400" b="0" i="0">
+                <a:solidFill>
+                  <a:srgbClr val="6B6B6B"/>
+                </a:solidFill>
+                <a:latin typeface="Calibri"/>
+              </a:rPr>
+              <a:t>500 automated tests, on every change</a:t>
+            </a:r>
+          </a:p>
+        </p:txBody>
+      </p:sp>
+      <p:sp>
+        <p:nvSpPr>
+          <p:cNvPr id="14" name="Rounded Rectangle 13"/>
+          <p:cNvSpPr/>
+          <p:nvPr/>
+        </p:nvSpPr>
+        <p:spPr>
+          <a:xfrm>
+            <a:off x="640080" y="4480560"/>
+            <a:ext cx="10908792" cy="1234440"/>
+          </a:xfrm>
+          <a:prstGeom prst="roundRect">
+            <a:avLst>
+              <a:gd name="adj" fmla="val 6000"/>
+            </a:avLst>
+          </a:prstGeom>
+          <a:solidFill>
+            <a:srgbClr val="FBEFE6"/>
+          </a:solidFill>
+          <a:ln>
+            <a:noFill/>
+          </a:ln>
+          <a:effectLst/>
+        </p:spPr>
+        <p:style>
+          <a:lnRef idx="1">
+            <a:schemeClr val="accent1"/>
+          </a:lnRef>
+          <a:fillRef idx="3">
+            <a:schemeClr val="accent1"/>
+          </a:fillRef>
+          <a:effectRef idx="2">
+            <a:schemeClr val="accent1"/>
+          </a:effectRef>
+          <a:fontRef idx="minor">
+            <a:schemeClr val="lt1"/>
+          </a:fontRef>
+        </p:style>
+        <p:txBody>
+          <a:bodyPr rtlCol="0" anchor="ctr"/>
+          <a:lstStyle/>
+          <a:p>
+            <a:pPr algn="ctr"/>
+          </a:p>
+        </p:txBody>
+      </p:sp>
+      <p:sp>
+        <p:nvSpPr>
+          <p:cNvPr id="15" name="TextBox 14"/>
+          <p:cNvSpPr txBox="1"/>
+          <p:nvPr/>
+        </p:nvSpPr>
+        <p:spPr>
+          <a:xfrm>
+            <a:off x="822960" y="4480560"/>
+            <a:ext cx="10543032" cy="1234440"/>
+          </a:xfrm>
+          <a:prstGeom prst="rect">
+            <a:avLst/>
+          </a:prstGeom>
+          <a:noFill/>
+        </p:spPr>
+        <p:txBody>
+          <a:bodyPr wrap="square" anchor="ctr" tIns="27432" bIns="27432">
+            <a:spAutoFit/>
+          </a:bodyPr>
+          <a:lstStyle/>
+          <a:p>
+            <a:pPr algn="ctr">
+              <a:lnSpc>
+                <a:spcPct val="100000"/>
+              </a:lnSpc>
+            </a:pPr>
+            <a:r>
+              <a:rPr sz="1800" b="1" i="0">
+                <a:solidFill>
+                  <a:srgbClr val="DD8452"/>
+                </a:solidFill>
+                <a:latin typeface="Calibri"/>
+              </a:rPr>
+              <a:t>Data analysis, in one line:</a:t>
+            </a:r>
+          </a:p>
+          <a:p>
+            <a:pPr algn="ctr">
+              <a:lnSpc>
+                <a:spcPct val="100000"/>
+              </a:lnSpc>
+            </a:pPr>
+            <a:r>
+              <a:rPr sz="1800" b="0" i="0">
+                <a:solidFill>
+                  <a:srgbClr val="2A2A2A"/>
+                </a:solidFill>
+                <a:latin typeface="Calibri"/>
+              </a:rPr>
+              <a:t>We tested our own verifier, caught it at only 50% accuracy, and calibrated it to 83.3% — while the dangerous error (a false claim marked true) stayed at 0%.</a:t>
             </a:r>
           </a:p>
         </p:txBody>
@@ -7080,600 +8686,11 @@
                 </a:solidFill>
                 <a:latin typeface="Calibri"/>
               </a:rPr>
-              <a:t>The Proof: It Would Rather Fail Than Lie</a:t>
-            </a:r>
-          </a:p>
-        </p:txBody>
-      </p:sp>
-      <p:graphicFrame>
-        <p:nvGraphicFramePr>
-          <p:cNvPr id="5" name="Table 4"/>
-          <p:cNvGraphicFramePr>
-            <a:graphicFrameLocks noGrp="1"/>
-          </p:cNvGraphicFramePr>
-          <p:nvPr/>
-        </p:nvGraphicFramePr>
-        <p:xfrm>
-          <a:off x="640080" y="1737360"/>
-          <a:ext cx="10911535" cy="2514600"/>
-        </p:xfrm>
-        <a:graphic>
-          <a:graphicData uri="http://schemas.openxmlformats.org/drawingml/2006/table">
-            <a:tbl>
-              <a:tblPr firstRow="1" bandRow="1">
-                <a:tableStyleId>{5C22544A-7EE6-4342-B048-85BDC9FD1C3A}</a:tableStyleId>
-              </a:tblPr>
-              <a:tblGrid>
-                <a:gridCol w="2182307"/>
-                <a:gridCol w="2182307"/>
-                <a:gridCol w="2182307"/>
-                <a:gridCol w="2182307"/>
-                <a:gridCol w="2182307"/>
-              </a:tblGrid>
-              <a:tr h="502920">
-                <a:tc>
-                  <a:txBody>
-                    <a:bodyPr/>
-                    <a:lstStyle/>
-                    <a:p>
-                      <a:r>
-                        <a:rPr sz="1600" b="1" i="0">
-                          <a:solidFill>
-                            <a:srgbClr val="FFFFFF"/>
-                          </a:solidFill>
-                          <a:latin typeface="Calibri"/>
-                        </a:rPr>
-                        <a:t>Scenario</a:t>
-                      </a:r>
-                    </a:p>
-                  </a:txBody>
-                  <a:tcPr>
-                    <a:solidFill>
-                      <a:srgbClr val="4C72B0"/>
-                    </a:solidFill>
-                  </a:tcPr>
-                </a:tc>
-                <a:tc>
-                  <a:txBody>
-                    <a:bodyPr/>
-                    <a:lstStyle/>
-                    <a:p>
-                      <a:r>
-                        <a:rPr sz="1600" b="1" i="0">
-                          <a:solidFill>
-                            <a:srgbClr val="FFFFFF"/>
-                          </a:solidFill>
-                          <a:latin typeface="Calibri"/>
-                        </a:rPr>
-                        <a:t>Result</a:t>
-                      </a:r>
-                    </a:p>
-                  </a:txBody>
-                  <a:tcPr>
-                    <a:solidFill>
-                      <a:srgbClr val="4C72B0"/>
-                    </a:solidFill>
-                  </a:tcPr>
-                </a:tc>
-                <a:tc>
-                  <a:txBody>
-                    <a:bodyPr/>
-                    <a:lstStyle/>
-                    <a:p>
-                      <a:r>
-                        <a:rPr sz="1600" b="1" i="0">
-                          <a:solidFill>
-                            <a:srgbClr val="FFFFFF"/>
-                          </a:solidFill>
-                          <a:latin typeface="Calibri"/>
-                        </a:rPr>
-                        <a:t>Trust</a:t>
-                      </a:r>
-                    </a:p>
-                  </a:txBody>
-                  <a:tcPr>
-                    <a:solidFill>
-                      <a:srgbClr val="4C72B0"/>
-                    </a:solidFill>
-                  </a:tcPr>
-                </a:tc>
-                <a:tc>
-                  <a:txBody>
-                    <a:bodyPr/>
-                    <a:lstStyle/>
-                    <a:p>
-                      <a:r>
-                        <a:rPr sz="1600" b="1" i="0">
-                          <a:solidFill>
-                            <a:srgbClr val="FFFFFF"/>
-                          </a:solidFill>
-                          <a:latin typeface="Calibri"/>
-                        </a:rPr>
-                        <a:t>ATS</a:t>
-                      </a:r>
-                    </a:p>
-                  </a:txBody>
-                  <a:tcPr>
-                    <a:solidFill>
-                      <a:srgbClr val="4C72B0"/>
-                    </a:solidFill>
-                  </a:tcPr>
-                </a:tc>
-                <a:tc>
-                  <a:txBody>
-                    <a:bodyPr/>
-                    <a:lstStyle/>
-                    <a:p>
-                      <a:r>
-                        <a:rPr sz="1600" b="1" i="0">
-                          <a:solidFill>
-                            <a:srgbClr val="FFFFFF"/>
-                          </a:solidFill>
-                          <a:latin typeface="Calibri"/>
-                        </a:rPr>
-                        <a:t>What happened</a:t>
-                      </a:r>
-                    </a:p>
-                  </a:txBody>
-                  <a:tcPr>
-                    <a:solidFill>
-                      <a:srgbClr val="4C72B0"/>
-                    </a:solidFill>
-                  </a:tcPr>
-                </a:tc>
-              </a:tr>
-              <a:tr h="502920">
-                <a:tc>
-                  <a:txBody>
-                    <a:bodyPr/>
-                    <a:lstStyle/>
-                    <a:p>
-                      <a:r>
-                        <a:rPr sz="1500" b="0" i="0">
-                          <a:solidFill>
-                            <a:srgbClr val="2A2A2A"/>
-                          </a:solidFill>
-                          <a:latin typeface="Calibri"/>
-                        </a:rPr>
-                        <a:t>1. Strong match</a:t>
-                      </a:r>
-                    </a:p>
-                  </a:txBody>
-                  <a:tcPr>
-                    <a:solidFill>
-                      <a:srgbClr val="FFFFFF"/>
-                    </a:solidFill>
-                  </a:tcPr>
-                </a:tc>
-                <a:tc>
-                  <a:txBody>
-                    <a:bodyPr/>
-                    <a:lstStyle/>
-                    <a:p>
-                      <a:r>
-                        <a:rPr sz="1500" b="0" i="0">
-                          <a:solidFill>
-                            <a:srgbClr val="2A2A2A"/>
-                          </a:solidFill>
-                          <a:latin typeface="Calibri"/>
-                        </a:rPr>
-                        <a:t>PASS</a:t>
-                      </a:r>
-                    </a:p>
-                  </a:txBody>
-                  <a:tcPr>
-                    <a:solidFill>
-                      <a:srgbClr val="FFFFFF"/>
-                    </a:solidFill>
-                  </a:tcPr>
-                </a:tc>
-                <a:tc>
-                  <a:txBody>
-                    <a:bodyPr/>
-                    <a:lstStyle/>
-                    <a:p>
-                      <a:r>
-                        <a:rPr sz="1500" b="0" i="0">
-                          <a:solidFill>
-                            <a:srgbClr val="2A2A2A"/>
-                          </a:solidFill>
-                          <a:latin typeface="Calibri"/>
-                        </a:rPr>
-                        <a:t>93/90</a:t>
-                      </a:r>
-                    </a:p>
-                  </a:txBody>
-                  <a:tcPr>
-                    <a:solidFill>
-                      <a:srgbClr val="FFFFFF"/>
-                    </a:solidFill>
-                  </a:tcPr>
-                </a:tc>
-                <a:tc>
-                  <a:txBody>
-                    <a:bodyPr/>
-                    <a:lstStyle/>
-                    <a:p>
-                      <a:r>
-                        <a:rPr sz="1500" b="0" i="0">
-                          <a:solidFill>
-                            <a:srgbClr val="2A2A2A"/>
-                          </a:solidFill>
-                          <a:latin typeface="Calibri"/>
-                        </a:rPr>
-                        <a:t>95/85</a:t>
-                      </a:r>
-                    </a:p>
-                  </a:txBody>
-                  <a:tcPr>
-                    <a:solidFill>
-                      <a:srgbClr val="FFFFFF"/>
-                    </a:solidFill>
-                  </a:tcPr>
-                </a:tc>
-                <a:tc>
-                  <a:txBody>
-                    <a:bodyPr/>
-                    <a:lstStyle/>
-                    <a:p>
-                      <a:r>
-                        <a:rPr sz="1500" b="0" i="0">
-                          <a:solidFill>
-                            <a:srgbClr val="2A2A2A"/>
-                          </a:solidFill>
-                          <a:latin typeface="Calibri"/>
-                        </a:rPr>
-                        <a:t>Real overlap; second draft passed too, but scored lower - kept the first</a:t>
-                      </a:r>
-                    </a:p>
-                  </a:txBody>
-                  <a:tcPr>
-                    <a:solidFill>
-                      <a:srgbClr val="FFFFFF"/>
-                    </a:solidFill>
-                  </a:tcPr>
-                </a:tc>
-              </a:tr>
-              <a:tr h="502920">
-                <a:tc>
-                  <a:txBody>
-                    <a:bodyPr/>
-                    <a:lstStyle/>
-                    <a:p>
-                      <a:r>
-                        <a:rPr sz="1500" b="0" i="0">
-                          <a:solidFill>
-                            <a:srgbClr val="2A2A2A"/>
-                          </a:solidFill>
-                          <a:latin typeface="Calibri"/>
-                        </a:rPr>
-                        <a:t>2. Partial match</a:t>
-                      </a:r>
-                    </a:p>
-                  </a:txBody>
-                  <a:tcPr>
-                    <a:solidFill>
-                      <a:srgbClr val="F7F9FC"/>
-                    </a:solidFill>
-                  </a:tcPr>
-                </a:tc>
-                <a:tc>
-                  <a:txBody>
-                    <a:bodyPr/>
-                    <a:lstStyle/>
-                    <a:p>
-                      <a:r>
-                        <a:rPr sz="1500" b="0" i="0">
-                          <a:solidFill>
-                            <a:srgbClr val="2A2A2A"/>
-                          </a:solidFill>
-                          <a:latin typeface="Calibri"/>
-                        </a:rPr>
-                        <a:t>FAIL</a:t>
-                      </a:r>
-                    </a:p>
-                  </a:txBody>
-                  <a:tcPr>
-                    <a:solidFill>
-                      <a:srgbClr val="F7F9FC"/>
-                    </a:solidFill>
-                  </a:tcPr>
-                </a:tc>
-                <a:tc>
-                  <a:txBody>
-                    <a:bodyPr/>
-                    <a:lstStyle/>
-                    <a:p>
-                      <a:r>
-                        <a:rPr sz="1500" b="0" i="0">
-                          <a:solidFill>
-                            <a:srgbClr val="2A2A2A"/>
-                          </a:solidFill>
-                          <a:latin typeface="Calibri"/>
-                        </a:rPr>
-                        <a:t>81/90</a:t>
-                      </a:r>
-                    </a:p>
-                  </a:txBody>
-                  <a:tcPr>
-                    <a:solidFill>
-                      <a:srgbClr val="F7F9FC"/>
-                    </a:solidFill>
-                  </a:tcPr>
-                </a:tc>
-                <a:tc>
-                  <a:txBody>
-                    <a:bodyPr/>
-                    <a:lstStyle/>
-                    <a:p>
-                      <a:r>
-                        <a:rPr sz="1500" b="0" i="0">
-                          <a:solidFill>
-                            <a:srgbClr val="2A2A2A"/>
-                          </a:solidFill>
-                          <a:latin typeface="Calibri"/>
-                        </a:rPr>
-                        <a:t>63/85</a:t>
-                      </a:r>
-                    </a:p>
-                  </a:txBody>
-                  <a:tcPr>
-                    <a:solidFill>
-                      <a:srgbClr val="F7F9FC"/>
-                    </a:solidFill>
-                  </a:tcPr>
-                </a:tc>
-                <a:tc>
-                  <a:txBody>
-                    <a:bodyPr/>
-                    <a:lstStyle/>
-                    <a:p>
-                      <a:r>
-                        <a:rPr sz="1500" b="0" i="0">
-                          <a:solidFill>
-                            <a:srgbClr val="2A2A2A"/>
-                          </a:solidFill>
-                          <a:latin typeface="Calibri"/>
-                        </a:rPr>
-                        <a:t>Honest gaps: evidence has no domain specifics to invent</a:t>
-                      </a:r>
-                    </a:p>
-                  </a:txBody>
-                  <a:tcPr>
-                    <a:solidFill>
-                      <a:srgbClr val="F7F9FC"/>
-                    </a:solidFill>
-                  </a:tcPr>
-                </a:tc>
-              </a:tr>
-              <a:tr h="502920">
-                <a:tc>
-                  <a:txBody>
-                    <a:bodyPr/>
-                    <a:lstStyle/>
-                    <a:p>
-                      <a:r>
-                        <a:rPr sz="1500" b="0" i="0">
-                          <a:solidFill>
-                            <a:srgbClr val="2A2A2A"/>
-                          </a:solidFill>
-                          <a:latin typeface="Calibri"/>
-                        </a:rPr>
-                        <a:t>3. Inflation pressure</a:t>
-                      </a:r>
-                    </a:p>
-                  </a:txBody>
-                  <a:tcPr>
-                    <a:solidFill>
-                      <a:srgbClr val="FFFFFF"/>
-                    </a:solidFill>
-                  </a:tcPr>
-                </a:tc>
-                <a:tc>
-                  <a:txBody>
-                    <a:bodyPr/>
-                    <a:lstStyle/>
-                    <a:p>
-                      <a:r>
-                        <a:rPr sz="1500" b="0" i="0">
-                          <a:solidFill>
-                            <a:srgbClr val="2A2A2A"/>
-                          </a:solidFill>
-                          <a:latin typeface="Calibri"/>
-                        </a:rPr>
-                        <a:t>FAIL</a:t>
-                      </a:r>
-                    </a:p>
-                  </a:txBody>
-                  <a:tcPr>
-                    <a:solidFill>
-                      <a:srgbClr val="FFFFFF"/>
-                    </a:solidFill>
-                  </a:tcPr>
-                </a:tc>
-                <a:tc>
-                  <a:txBody>
-                    <a:bodyPr/>
-                    <a:lstStyle/>
-                    <a:p>
-                      <a:r>
-                        <a:rPr sz="1500" b="0" i="0">
-                          <a:solidFill>
-                            <a:srgbClr val="2A2A2A"/>
-                          </a:solidFill>
-                          <a:latin typeface="Calibri"/>
-                        </a:rPr>
-                        <a:t>83/90</a:t>
-                      </a:r>
-                    </a:p>
-                  </a:txBody>
-                  <a:tcPr>
-                    <a:solidFill>
-                      <a:srgbClr val="FFFFFF"/>
-                    </a:solidFill>
-                  </a:tcPr>
-                </a:tc>
-                <a:tc>
-                  <a:txBody>
-                    <a:bodyPr/>
-                    <a:lstStyle/>
-                    <a:p>
-                      <a:r>
-                        <a:rPr sz="1500" b="0" i="0">
-                          <a:solidFill>
-                            <a:srgbClr val="2A2A2A"/>
-                          </a:solidFill>
-                          <a:latin typeface="Calibri"/>
-                        </a:rPr>
-                        <a:t>42/85</a:t>
-                      </a:r>
-                    </a:p>
-                  </a:txBody>
-                  <a:tcPr>
-                    <a:solidFill>
-                      <a:srgbClr val="FFFFFF"/>
-                    </a:solidFill>
-                  </a:tcPr>
-                </a:tc>
-                <a:tc>
-                  <a:txBody>
-                    <a:bodyPr/>
-                    <a:lstStyle/>
-                    <a:p>
-                      <a:r>
-                        <a:rPr sz="1500" b="0" i="0">
-                          <a:solidFill>
-                            <a:srgbClr val="2A2A2A"/>
-                          </a:solidFill>
-                          <a:latin typeface="Calibri"/>
-                        </a:rPr>
-                        <a:t>Writer drifted toward overstatement; harness caught it</a:t>
-                      </a:r>
-                    </a:p>
-                  </a:txBody>
-                  <a:tcPr>
-                    <a:solidFill>
-                      <a:srgbClr val="FFFFFF"/>
-                    </a:solidFill>
-                  </a:tcPr>
-                </a:tc>
-              </a:tr>
-              <a:tr h="502920">
-                <a:tc>
-                  <a:txBody>
-                    <a:bodyPr/>
-                    <a:lstStyle/>
-                    <a:p>
-                      <a:r>
-                        <a:rPr sz="1500" b="0" i="0">
-                          <a:solidFill>
-                            <a:srgbClr val="2A2A2A"/>
-                          </a:solidFill>
-                          <a:latin typeface="Calibri"/>
-                        </a:rPr>
-                        <a:t>4. Wrong domain</a:t>
-                      </a:r>
-                    </a:p>
-                  </a:txBody>
-                  <a:tcPr>
-                    <a:solidFill>
-                      <a:srgbClr val="F7F9FC"/>
-                    </a:solidFill>
-                  </a:tcPr>
-                </a:tc>
-                <a:tc>
-                  <a:txBody>
-                    <a:bodyPr/>
-                    <a:lstStyle/>
-                    <a:p>
-                      <a:r>
-                        <a:rPr sz="1500" b="0" i="0">
-                          <a:solidFill>
-                            <a:srgbClr val="2A2A2A"/>
-                          </a:solidFill>
-                          <a:latin typeface="Calibri"/>
-                        </a:rPr>
-                        <a:t>FAIL</a:t>
-                      </a:r>
-                    </a:p>
-                  </a:txBody>
-                  <a:tcPr>
-                    <a:solidFill>
-                      <a:srgbClr val="F7F9FC"/>
-                    </a:solidFill>
-                  </a:tcPr>
-                </a:tc>
-                <a:tc>
-                  <a:txBody>
-                    <a:bodyPr/>
-                    <a:lstStyle/>
-                    <a:p>
-                      <a:r>
-                        <a:rPr sz="1500" b="0" i="0">
-                          <a:solidFill>
-                            <a:srgbClr val="2A2A2A"/>
-                          </a:solidFill>
-                          <a:latin typeface="Calibri"/>
-                        </a:rPr>
-                        <a:t>100/90</a:t>
-                      </a:r>
-                    </a:p>
-                  </a:txBody>
-                  <a:tcPr>
-                    <a:solidFill>
-                      <a:srgbClr val="F7F9FC"/>
-                    </a:solidFill>
-                  </a:tcPr>
-                </a:tc>
-                <a:tc>
-                  <a:txBody>
-                    <a:bodyPr/>
-                    <a:lstStyle/>
-                    <a:p>
-                      <a:r>
-                        <a:rPr sz="1500" b="0" i="0">
-                          <a:solidFill>
-                            <a:srgbClr val="2A2A2A"/>
-                          </a:solidFill>
-                          <a:latin typeface="Calibri"/>
-                        </a:rPr>
-                        <a:t>0/85</a:t>
-                      </a:r>
-                    </a:p>
-                  </a:txBody>
-                  <a:tcPr>
-                    <a:solidFill>
-                      <a:srgbClr val="F7F9FC"/>
-                    </a:solidFill>
-                  </a:tcPr>
-                </a:tc>
-                <a:tc>
-                  <a:txBody>
-                    <a:bodyPr/>
-                    <a:lstStyle/>
-                    <a:p>
-                      <a:r>
-                        <a:rPr sz="1500" b="0" i="0">
-                          <a:solidFill>
-                            <a:srgbClr val="2A2A2A"/>
-                          </a:solidFill>
-                          <a:latin typeface="Calibri"/>
-                        </a:rPr>
-                        <a:t>Writer refused to invent experience; every claim true</a:t>
-                      </a:r>
-                    </a:p>
-                  </a:txBody>
-                  <a:tcPr>
-                    <a:solidFill>
-                      <a:srgbClr val="F7F9FC"/>
-                    </a:solidFill>
-                  </a:tcPr>
-                </a:tc>
-              </a:tr>
-            </a:tbl>
-          </a:graphicData>
-        </a:graphic>
-      </p:graphicFrame>
+              <a:t>The Proof: It Chose Honesty Over a Fake Match</a:t>
+            </a:r>
+          </a:p>
+        </p:txBody>
+      </p:sp>
       <p:sp>
         <p:nvSpPr>
           <p:cNvPr id="6" name="TextBox 5"/>
@@ -7704,6 +8721,483 @@
                 <a:latin typeface="Calibri"/>
               </a:rPr>
               <a:t>TrustResume | MSAI 699 Capstone Final Presentation</a:t>
+            </a:r>
+          </a:p>
+        </p:txBody>
+      </p:sp>
+      <p:sp>
+        <p:nvSpPr>
+          <p:cNvPr id="7" name="Rounded Rectangle 6"/>
+          <p:cNvSpPr/>
+          <p:nvPr/>
+        </p:nvSpPr>
+        <p:spPr>
+          <a:xfrm>
+            <a:off x="640080" y="1325880"/>
+            <a:ext cx="10908792" cy="841248"/>
+          </a:xfrm>
+          <a:prstGeom prst="roundRect">
+            <a:avLst>
+              <a:gd name="adj" fmla="val 6000"/>
+            </a:avLst>
+          </a:prstGeom>
+          <a:solidFill>
+            <a:srgbClr val="E9EFF8"/>
+          </a:solidFill>
+          <a:ln w="15875">
+            <a:solidFill>
+              <a:srgbClr val="C7D6EC"/>
+            </a:solidFill>
+          </a:ln>
+          <a:effectLst/>
+        </p:spPr>
+        <p:style>
+          <a:lnRef idx="1">
+            <a:schemeClr val="accent1"/>
+          </a:lnRef>
+          <a:fillRef idx="3">
+            <a:schemeClr val="accent1"/>
+          </a:fillRef>
+          <a:effectRef idx="2">
+            <a:schemeClr val="accent1"/>
+          </a:effectRef>
+          <a:fontRef idx="minor">
+            <a:schemeClr val="lt1"/>
+          </a:fontRef>
+        </p:style>
+        <p:txBody>
+          <a:bodyPr rtlCol="0" anchor="ctr"/>
+          <a:lstStyle/>
+          <a:p>
+            <a:pPr algn="ctr"/>
+          </a:p>
+        </p:txBody>
+      </p:sp>
+      <p:sp>
+        <p:nvSpPr>
+          <p:cNvPr id="8" name="TextBox 7"/>
+          <p:cNvSpPr txBox="1"/>
+          <p:nvPr/>
+        </p:nvSpPr>
+        <p:spPr>
+          <a:xfrm>
+            <a:off x="777240" y="1325880"/>
+            <a:ext cx="10634472" cy="841248"/>
+          </a:xfrm>
+          <a:prstGeom prst="rect">
+            <a:avLst/>
+          </a:prstGeom>
+          <a:noFill/>
+        </p:spPr>
+        <p:txBody>
+          <a:bodyPr wrap="square" anchor="ctr" tIns="27432" bIns="27432">
+            <a:spAutoFit/>
+          </a:bodyPr>
+          <a:lstStyle/>
+          <a:p>
+            <a:pPr algn="ctr"/>
+            <a:r>
+              <a:rPr sz="2000" b="1" i="0">
+                <a:solidFill>
+                  <a:srgbClr val="4C72B0"/>
+                </a:solidFill>
+                <a:latin typeface="Calibri"/>
+              </a:rPr>
+              <a:t>Backend Engineer résumé</a:t>
+            </a:r>
+            <a:r>
+              <a:rPr sz="2000" b="0" i="0">
+                <a:solidFill>
+                  <a:srgbClr val="2A2A2A"/>
+                </a:solidFill>
+                <a:latin typeface="Calibri"/>
+              </a:rPr>
+              <a:t>   →   applied to an </a:t>
+            </a:r>
+            <a:r>
+              <a:rPr sz="2000" b="1" i="0">
+                <a:solidFill>
+                  <a:srgbClr val="DD8452"/>
+                </a:solidFill>
+                <a:latin typeface="Calibri"/>
+              </a:rPr>
+              <a:t>iOS Developer job</a:t>
+            </a:r>
+            <a:r>
+              <a:rPr sz="2000" b="0" i="1">
+                <a:solidFill>
+                  <a:srgbClr val="2A2A2A"/>
+                </a:solidFill>
+                <a:latin typeface="Calibri"/>
+              </a:rPr>
+              <a:t>  (zero iOS experience)</a:t>
+            </a:r>
+          </a:p>
+        </p:txBody>
+      </p:sp>
+      <p:sp>
+        <p:nvSpPr>
+          <p:cNvPr id="9" name="Rounded Rectangle 8"/>
+          <p:cNvSpPr/>
+          <p:nvPr/>
+        </p:nvSpPr>
+        <p:spPr>
+          <a:xfrm>
+            <a:off x="822960" y="2377440"/>
+            <a:ext cx="5120640" cy="1783080"/>
+          </a:xfrm>
+          <a:prstGeom prst="roundRect">
+            <a:avLst>
+              <a:gd name="adj" fmla="val 6000"/>
+            </a:avLst>
+          </a:prstGeom>
+          <a:solidFill>
+            <a:srgbClr val="E6F1EA"/>
+          </a:solidFill>
+          <a:ln>
+            <a:noFill/>
+          </a:ln>
+          <a:effectLst/>
+        </p:spPr>
+        <p:style>
+          <a:lnRef idx="1">
+            <a:schemeClr val="accent1"/>
+          </a:lnRef>
+          <a:fillRef idx="3">
+            <a:schemeClr val="accent1"/>
+          </a:fillRef>
+          <a:effectRef idx="2">
+            <a:schemeClr val="accent1"/>
+          </a:effectRef>
+          <a:fontRef idx="minor">
+            <a:schemeClr val="lt1"/>
+          </a:fontRef>
+        </p:style>
+        <p:txBody>
+          <a:bodyPr rtlCol="0" anchor="ctr"/>
+          <a:lstStyle/>
+          <a:p>
+            <a:pPr algn="ctr"/>
+          </a:p>
+        </p:txBody>
+      </p:sp>
+      <p:sp>
+        <p:nvSpPr>
+          <p:cNvPr id="10" name="TextBox 9"/>
+          <p:cNvSpPr txBox="1"/>
+          <p:nvPr/>
+        </p:nvSpPr>
+        <p:spPr>
+          <a:xfrm>
+            <a:off x="914400" y="2377440"/>
+            <a:ext cx="4937760" cy="1783080"/>
+          </a:xfrm>
+          <a:prstGeom prst="rect">
+            <a:avLst/>
+          </a:prstGeom>
+          <a:noFill/>
+        </p:spPr>
+        <p:txBody>
+          <a:bodyPr wrap="square" anchor="ctr" tIns="27432" bIns="27432">
+            <a:spAutoFit/>
+          </a:bodyPr>
+          <a:lstStyle/>
+          <a:p>
+            <a:pPr algn="ctr">
+              <a:lnSpc>
+                <a:spcPct val="95000"/>
+              </a:lnSpc>
+            </a:pPr>
+            <a:r>
+              <a:rPr sz="1800" b="1" i="0">
+                <a:solidFill>
+                  <a:srgbClr val="2A2A2A"/>
+                </a:solidFill>
+                <a:latin typeface="Calibri"/>
+              </a:rPr>
+              <a:t>Trust Score</a:t>
+            </a:r>
+          </a:p>
+          <a:p>
+            <a:pPr algn="ctr">
+              <a:lnSpc>
+                <a:spcPct val="95000"/>
+              </a:lnSpc>
+            </a:pPr>
+            <a:r>
+              <a:rPr sz="6600" b="1" i="0">
+                <a:solidFill>
+                  <a:srgbClr val="4F935F"/>
+                </a:solidFill>
+                <a:latin typeface="Calibri"/>
+              </a:rPr>
+              <a:t>100</a:t>
+            </a:r>
+          </a:p>
+          <a:p>
+            <a:pPr algn="ctr">
+              <a:lnSpc>
+                <a:spcPct val="95000"/>
+              </a:lnSpc>
+            </a:pPr>
+            <a:r>
+              <a:rPr sz="1600" b="0" i="0">
+                <a:solidFill>
+                  <a:srgbClr val="2A2A2A"/>
+                </a:solidFill>
+                <a:latin typeface="Calibri"/>
+              </a:rPr>
+              <a:t>Every claim was true</a:t>
+            </a:r>
+          </a:p>
+        </p:txBody>
+      </p:sp>
+      <p:sp>
+        <p:nvSpPr>
+          <p:cNvPr id="11" name="Rounded Rectangle 10"/>
+          <p:cNvSpPr/>
+          <p:nvPr/>
+        </p:nvSpPr>
+        <p:spPr>
+          <a:xfrm>
+            <a:off x="6245352" y="2377440"/>
+            <a:ext cx="5120640" cy="1783080"/>
+          </a:xfrm>
+          <a:prstGeom prst="roundRect">
+            <a:avLst>
+              <a:gd name="adj" fmla="val 6000"/>
+            </a:avLst>
+          </a:prstGeom>
+          <a:solidFill>
+            <a:srgbClr val="FBECEC"/>
+          </a:solidFill>
+          <a:ln>
+            <a:noFill/>
+          </a:ln>
+          <a:effectLst/>
+        </p:spPr>
+        <p:style>
+          <a:lnRef idx="1">
+            <a:schemeClr val="accent1"/>
+          </a:lnRef>
+          <a:fillRef idx="3">
+            <a:schemeClr val="accent1"/>
+          </a:fillRef>
+          <a:effectRef idx="2">
+            <a:schemeClr val="accent1"/>
+          </a:effectRef>
+          <a:fontRef idx="minor">
+            <a:schemeClr val="lt1"/>
+          </a:fontRef>
+        </p:style>
+        <p:txBody>
+          <a:bodyPr rtlCol="0" anchor="ctr"/>
+          <a:lstStyle/>
+          <a:p>
+            <a:pPr algn="ctr"/>
+          </a:p>
+        </p:txBody>
+      </p:sp>
+      <p:sp>
+        <p:nvSpPr>
+          <p:cNvPr id="12" name="TextBox 11"/>
+          <p:cNvSpPr txBox="1"/>
+          <p:nvPr/>
+        </p:nvSpPr>
+        <p:spPr>
+          <a:xfrm>
+            <a:off x="6336792" y="2377440"/>
+            <a:ext cx="4937760" cy="1783080"/>
+          </a:xfrm>
+          <a:prstGeom prst="rect">
+            <a:avLst/>
+          </a:prstGeom>
+          <a:noFill/>
+        </p:spPr>
+        <p:txBody>
+          <a:bodyPr wrap="square" anchor="ctr" tIns="27432" bIns="27432">
+            <a:spAutoFit/>
+          </a:bodyPr>
+          <a:lstStyle/>
+          <a:p>
+            <a:pPr algn="ctr">
+              <a:lnSpc>
+                <a:spcPct val="95000"/>
+              </a:lnSpc>
+            </a:pPr>
+            <a:r>
+              <a:rPr sz="1800" b="1" i="0">
+                <a:solidFill>
+                  <a:srgbClr val="2A2A2A"/>
+                </a:solidFill>
+                <a:latin typeface="Calibri"/>
+              </a:rPr>
+              <a:t>ATS Match</a:t>
+            </a:r>
+          </a:p>
+          <a:p>
+            <a:pPr algn="ctr">
+              <a:lnSpc>
+                <a:spcPct val="95000"/>
+              </a:lnSpc>
+            </a:pPr>
+            <a:r>
+              <a:rPr sz="6600" b="1" i="0">
+                <a:solidFill>
+                  <a:srgbClr val="C44E52"/>
+                </a:solidFill>
+                <a:latin typeface="Calibri"/>
+              </a:rPr>
+              <a:t>0</a:t>
+            </a:r>
+          </a:p>
+          <a:p>
+            <a:pPr algn="ctr">
+              <a:lnSpc>
+                <a:spcPct val="95000"/>
+              </a:lnSpc>
+            </a:pPr>
+            <a:r>
+              <a:rPr sz="1600" b="0" i="0">
+                <a:solidFill>
+                  <a:srgbClr val="2A2A2A"/>
+                </a:solidFill>
+                <a:latin typeface="Calibri"/>
+              </a:rPr>
+              <a:t>No matching experience</a:t>
+            </a:r>
+          </a:p>
+        </p:txBody>
+      </p:sp>
+      <p:sp>
+        <p:nvSpPr>
+          <p:cNvPr id="13" name="TextBox 12"/>
+          <p:cNvSpPr txBox="1"/>
+          <p:nvPr/>
+        </p:nvSpPr>
+        <p:spPr>
+          <a:xfrm>
+            <a:off x="914400" y="4343400"/>
+            <a:ext cx="10360152" cy="1280160"/>
+          </a:xfrm>
+          <a:prstGeom prst="rect">
+            <a:avLst/>
+          </a:prstGeom>
+          <a:noFill/>
+        </p:spPr>
+        <p:txBody>
+          <a:bodyPr wrap="square" anchor="t" tIns="27432" bIns="27432">
+            <a:spAutoFit/>
+          </a:bodyPr>
+          <a:lstStyle/>
+          <a:p>
+            <a:pPr algn="l">
+              <a:lnSpc>
+                <a:spcPct val="112000"/>
+              </a:lnSpc>
+            </a:pPr>
+            <a:r>
+              <a:rPr sz="2000" b="1" i="0">
+                <a:solidFill>
+                  <a:srgbClr val="4F935F"/>
+                </a:solidFill>
+                <a:latin typeface="Calibri"/>
+              </a:rPr>
+              <a:t>✓  </a:t>
+            </a:r>
+            <a:r>
+              <a:rPr sz="2000" b="0" i="0">
+                <a:solidFill>
+                  <a:srgbClr val="2A2A2A"/>
+                </a:solidFill>
+                <a:latin typeface="Calibri"/>
+              </a:rPr>
+              <a:t>Every claim it made was true</a:t>
+            </a:r>
+          </a:p>
+          <a:p>
+            <a:pPr algn="l">
+              <a:lnSpc>
+                <a:spcPct val="112000"/>
+              </a:lnSpc>
+            </a:pPr>
+            <a:r>
+              <a:rPr sz="2000" b="1" i="0">
+                <a:solidFill>
+                  <a:srgbClr val="C44E52"/>
+                </a:solidFill>
+                <a:latin typeface="Calibri"/>
+              </a:rPr>
+              <a:t>✗  </a:t>
+            </a:r>
+            <a:r>
+              <a:rPr sz="2000" b="0" i="0">
+                <a:solidFill>
+                  <a:srgbClr val="2A2A2A"/>
+                </a:solidFill>
+                <a:latin typeface="Calibri"/>
+              </a:rPr>
+              <a:t>No iOS experience — and it refused to invent any</a:t>
+            </a:r>
+          </a:p>
+          <a:p>
+            <a:pPr algn="l">
+              <a:lnSpc>
+                <a:spcPct val="112000"/>
+              </a:lnSpc>
+            </a:pPr>
+            <a:r>
+              <a:rPr sz="2000" b="1" i="0">
+                <a:solidFill>
+                  <a:srgbClr val="4F935F"/>
+                </a:solidFill>
+                <a:latin typeface="Calibri"/>
+              </a:rPr>
+              <a:t>✓  </a:t>
+            </a:r>
+            <a:r>
+              <a:rPr sz="2000" b="0" i="0">
+                <a:solidFill>
+                  <a:srgbClr val="2A2A2A"/>
+                </a:solidFill>
+                <a:latin typeface="Calibri"/>
+              </a:rPr>
+              <a:t>Reported an honest failure instead of a fabricated pass</a:t>
+            </a:r>
+          </a:p>
+        </p:txBody>
+      </p:sp>
+      <p:sp>
+        <p:nvSpPr>
+          <p:cNvPr id="14" name="TextBox 13"/>
+          <p:cNvSpPr txBox="1"/>
+          <p:nvPr/>
+        </p:nvSpPr>
+        <p:spPr>
+          <a:xfrm>
+            <a:off x="640080" y="5715000"/>
+            <a:ext cx="10908792" cy="548640"/>
+          </a:xfrm>
+          <a:prstGeom prst="rect">
+            <a:avLst/>
+          </a:prstGeom>
+          <a:noFill/>
+        </p:spPr>
+        <p:txBody>
+          <a:bodyPr wrap="square" anchor="ctr" tIns="27432" bIns="27432">
+            <a:spAutoFit/>
+          </a:bodyPr>
+          <a:lstStyle/>
+          <a:p>
+            <a:pPr algn="ctr"/>
+            <a:r>
+              <a:rPr sz="2200" b="1" i="1">
+                <a:solidFill>
+                  <a:srgbClr val="DD8452"/>
+                </a:solidFill>
+                <a:latin typeface="Calibri"/>
+              </a:rPr>
+              <a:t>It would rather fail you than lie for you.</a:t>
             </a:r>
           </a:p>
         </p:txBody>

</xml_diff>